<commit_message>
feat: unify study scheduling and import university classes
</commit_message>
<xml_diff>
--- a/presentation/pitch-2026-10-22/output/CampusPulse-AI-Pitch-2026-10-22-final.pptx
+++ b/presentation/pitch-2026-10-22/output/CampusPulse-AI-Pitch-2026-10-22-final.pptx
@@ -2,19 +2,19 @@
 <file path=ppt/presentation.xml><?xml version="1.0" encoding="utf-8"?>
 <p:presentation xmlns:p="http://schemas.openxmlformats.org/presentationml/2006/main">
   <p:sldMasterIdLst>
-    <p:sldMasterId xmlns:r="http://schemas.openxmlformats.org/officeDocument/2006/relationships" id="2147483648" r:id="Rd60165c016bc4cb0"/>
+    <p:sldMasterId xmlns:r="http://schemas.openxmlformats.org/officeDocument/2006/relationships" id="2147483648" r:id="Ra031d674226d40da"/>
   </p:sldMasterIdLst>
   <p:notesMasterIdLst>
-    <p:notesMasterId xmlns:r="http://schemas.openxmlformats.org/officeDocument/2006/relationships" r:id="R2ed3e59e856848e6"/>
+    <p:notesMasterId xmlns:r="http://schemas.openxmlformats.org/officeDocument/2006/relationships" r:id="R4c456eff0e384f89"/>
   </p:notesMasterIdLst>
   <p:sldIdLst>
-    <p:sldId xmlns:r="http://schemas.openxmlformats.org/officeDocument/2006/relationships" id="256" r:id="R92c89ea3b4844ca9"/>
-    <p:sldId xmlns:r="http://schemas.openxmlformats.org/officeDocument/2006/relationships" id="257" r:id="R4ae45426b79b4f82"/>
-    <p:sldId xmlns:r="http://schemas.openxmlformats.org/officeDocument/2006/relationships" id="258" r:id="R4d91989696814040"/>
-    <p:sldId xmlns:r="http://schemas.openxmlformats.org/officeDocument/2006/relationships" id="259" r:id="Ra725a463ddff4f4e"/>
-    <p:sldId xmlns:r="http://schemas.openxmlformats.org/officeDocument/2006/relationships" id="260" r:id="R4e385372c52b4bc3"/>
-    <p:sldId xmlns:r="http://schemas.openxmlformats.org/officeDocument/2006/relationships" id="261" r:id="Rc0ef8e36174b43ff"/>
-    <p:sldId xmlns:r="http://schemas.openxmlformats.org/officeDocument/2006/relationships" id="262" r:id="R5d86c72ffd204fd9"/>
+    <p:sldId xmlns:r="http://schemas.openxmlformats.org/officeDocument/2006/relationships" id="256" r:id="R017f9f1883ad4a20"/>
+    <p:sldId xmlns:r="http://schemas.openxmlformats.org/officeDocument/2006/relationships" id="257" r:id="Recf4954d59e64b73"/>
+    <p:sldId xmlns:r="http://schemas.openxmlformats.org/officeDocument/2006/relationships" id="258" r:id="R4367bfc1a59a4891"/>
+    <p:sldId xmlns:r="http://schemas.openxmlformats.org/officeDocument/2006/relationships" id="259" r:id="R38d9e35494454fb5"/>
+    <p:sldId xmlns:r="http://schemas.openxmlformats.org/officeDocument/2006/relationships" id="260" r:id="R32219a901af946c4"/>
+    <p:sldId xmlns:r="http://schemas.openxmlformats.org/officeDocument/2006/relationships" id="261" r:id="R0593544b661149f7"/>
+    <p:sldId xmlns:r="http://schemas.openxmlformats.org/officeDocument/2006/relationships" id="262" r:id="Rd8990348c97f4df6"/>
   </p:sldIdLst>
   <p:sldSz cx="12192000" cy="6858000"/>
   <p:notesSz cx="6858000" cy="9144000"/>
@@ -448,7 +448,7 @@
           <a:lstStyle xmlns:a="http://schemas.openxmlformats.org/drawingml/2006/main"/>
           <a:p xmlns:a="http://schemas.openxmlformats.org/drawingml/2006/main">
             <a:r>
-              <a:t>Проблема сформулирована как пользовательский сценарий, без заявления о проведённом исследовании или измеренном эффекте. Moodle iCalendar даёт сроки, но не трудоёмкость. Архитектура и исторический облачный статус: README.md, setup/RECOVERY-WEB-HANDOFF.md, setup/RECOVERY-WEB-VALIDATION.md, setup/RECOVERY-ROLLOUT-2026-10-20.md из main 4a0858a00b3f1c1c2bf382981b0400f212f06fb8. Облачный checkpoint относится к 20.10.2026. Свежие локальные результаты ветки codex/pitch-ui-demo относятся к 21.10.2026 и описаны в LOCAL-VALIDATION.md. setup/PITCH-CLOUD-HANDOFF.md отсутствовал при подготовке. Персональные данные и private resource identifiers исключены.</a:t>
+              <a:t>Слайд отражает локальный реализованный сценарий и ограничения облачной приёмки. PDF/PNG/JPEG отправляются модели только по кнопке, распознанные пары требуют проверки и сохранения. Пары не экспортируются автоматически в Calendar. Recovery использует отдельное подтверждение версии и независимый verify. Новый read-only cloud study-agent не имеет инструментов записи. Локальные внешние сервисы синтетические, реальная модель OCR не тестировалась. Исходники UI: codex/pitch-ui-demo, база acf869b1eff2e50f2669c3f9f824b7b83cfb534d, 22.10.2026. Локальные проверки описаны в SCHEDULE-VALIDATION-2026-10-22.md. Облачный источник: setup/PITCH-CLOUD-HANDOFF.md из origin/codex/pitch-agent-cloud, SHA 1382f49aaba7c37c6571bbd8355349064e039012. Handoff описывает read-only study agent; live website acceptance pending, recovery/Calendar writes не включены. Исторический checkpoint 20.10 не считается новой приёмкой. Личные данные, credentials и resource identifiers исключены.</a:t>
             </a:r>
           </a:p>
         </p:txBody>
@@ -518,7 +518,7 @@
           <a:lstStyle xmlns:a="http://schemas.openxmlformats.org/drawingml/2006/main"/>
           <a:p xmlns:a="http://schemas.openxmlformats.org/drawingml/2006/main">
             <a:r>
-              <a:t>Фактический статус опубликованного приложения взят из README и checkpoint 20.10.2026. Текущий UI в main использует название Google AI, а презентация сохраняет запрошенное название CampusPulse AI. Ответ обычного чата сам по себе не записывает события Calendar. Архитектура и исторический облачный статус: README.md, setup/RECOVERY-WEB-HANDOFF.md, setup/RECOVERY-WEB-VALIDATION.md, setup/RECOVERY-ROLLOUT-2026-10-20.md из main 4a0858a00b3f1c1c2bf382981b0400f212f06fb8. Облачный checkpoint относится к 20.10.2026. Свежие локальные результаты ветки codex/pitch-ui-demo относятся к 21.10.2026 и описаны в LOCAL-VALIDATION.md. setup/PITCH-CLOUD-HANDOFF.md отсутствовал при подготовке. Персональные данные и private resource identifiers исключены.</a:t>
+              <a:t>Слайд отражает локальный реализованный сценарий и ограничения облачной приёмки. PDF/PNG/JPEG отправляются модели только по кнопке, распознанные пары требуют проверки и сохранения. Пары не экспортируются автоматически в Calendar. Recovery использует отдельное подтверждение версии и независимый verify. Новый read-only cloud study-agent не имеет инструментов записи. Локальные внешние сервисы синтетические, реальная модель OCR не тестировалась. Исходники UI: codex/pitch-ui-demo, база acf869b1eff2e50f2669c3f9f824b7b83cfb534d, 22.10.2026. Локальные проверки описаны в SCHEDULE-VALIDATION-2026-10-22.md. Облачный источник: setup/PITCH-CLOUD-HANDOFF.md из origin/codex/pitch-agent-cloud, SHA 1382f49aaba7c37c6571bbd8355349064e039012. Handoff описывает read-only study agent; live website acceptance pending, recovery/Calendar writes не включены. Исторический checkpoint 20.10 не считается новой приёмкой. Личные данные, credentials и resource identifiers исключены.</a:t>
             </a:r>
           </a:p>
         </p:txBody>
@@ -588,7 +588,7 @@
           <a:lstStyle xmlns:a="http://schemas.openxmlformats.org/drawingml/2006/main"/>
           <a:p xmlns:a="http://schemas.openxmlformats.org/drawingml/2006/main">
             <a:r>
-              <a:t>В implemented recovery чтение источников предшествует solve_repair. apply_plan требует отдельного согласия на сохранённую версию и хеш. verify_plan перечитывает результат. Этот процесс показан как реализованный контракт, а не пройденная персональная облачная приёмка. Источник: README, Recovery website integration handoff. Архитектура и исторический облачный статус: README.md, setup/RECOVERY-WEB-HANDOFF.md, setup/RECOVERY-WEB-VALIDATION.md, setup/RECOVERY-ROLLOUT-2026-10-20.md из main 4a0858a00b3f1c1c2bf382981b0400f212f06fb8. Облачный checkpoint относится к 20.10.2026. Свежие локальные результаты ветки codex/pitch-ui-demo относятся к 21.10.2026 и описаны в LOCAL-VALIDATION.md. setup/PITCH-CLOUD-HANDOFF.md отсутствовал при подготовке. Персональные данные и private resource identifiers исключены.</a:t>
+              <a:t>Слайд отражает локальный реализованный сценарий и ограничения облачной приёмки. PDF/PNG/JPEG отправляются модели только по кнопке, распознанные пары требуют проверки и сохранения. Пары не экспортируются автоматически в Calendar. Recovery использует отдельное подтверждение версии и независимый verify. Новый read-only cloud study-agent не имеет инструментов записи. Локальные внешние сервисы синтетические, реальная модель OCR не тестировалась. Исходники UI: codex/pitch-ui-demo, база acf869b1eff2e50f2669c3f9f824b7b83cfb534d, 22.10.2026. Локальные проверки описаны в SCHEDULE-VALIDATION-2026-10-22.md. Облачный источник: setup/PITCH-CLOUD-HANDOFF.md из origin/codex/pitch-agent-cloud, SHA 1382f49aaba7c37c6571bbd8355349064e039012. Handoff описывает read-only study agent; live website acceptance pending, recovery/Calendar writes не включены. Исторический checkpoint 20.10 не считается новой приёмкой. Личные данные, credentials и resource identifiers исключены.</a:t>
             </a:r>
           </a:p>
         </p:txBody>
@@ -658,7 +658,7 @@
           <a:lstStyle xmlns:a="http://schemas.openxmlformats.org/drawingml/2006/main"/>
           <a:p xmlns:a="http://schemas.openxmlformats.org/drawingml/2006/main">
             <a:r>
-              <a:t>Native editable shapes and attached connectors. Схема упрощена: Cloud Run также обращается к Firestore напрямую, MCP читает/пишет состояние в том же Firestore. Gemini API находится в обычном chat path. Recovery runtime использует Gemini через Vertex AI и приватный MCP. Пунктир обозначает отключённую опциональную композицию сайта. README, architecture section, and rollout checkpoint 20.10.2026. Архитектура и исторический облачный статус: README.md, setup/RECOVERY-WEB-HANDOFF.md, setup/RECOVERY-WEB-VALIDATION.md, setup/RECOVERY-ROLLOUT-2026-10-20.md из main 4a0858a00b3f1c1c2bf382981b0400f212f06fb8. Облачный checkpoint относится к 20.10.2026. Свежие локальные результаты ветки codex/pitch-ui-demo относятся к 21.10.2026 и описаны в LOCAL-VALIDATION.md. setup/PITCH-CLOUD-HANDOFF.md отсутствовал при подготовке. Персональные данные и private resource identifiers исключены.</a:t>
+              <a:t>Слайд отражает локальный реализованный сценарий и ограничения облачной приёмки. PDF/PNG/JPEG отправляются модели только по кнопке, распознанные пары требуют проверки и сохранения. Пары не экспортируются автоматически в Calendar. Recovery использует отдельное подтверждение версии и независимый verify. Новый read-only cloud study-agent не имеет инструментов записи. Локальные внешние сервисы синтетические, реальная модель OCR не тестировалась. Исходники UI: codex/pitch-ui-demo, база acf869b1eff2e50f2669c3f9f824b7b83cfb534d, 22.10.2026. Локальные проверки описаны в SCHEDULE-VALIDATION-2026-10-22.md. Облачный источник: setup/PITCH-CLOUD-HANDOFF.md из origin/codex/pitch-agent-cloud, SHA 1382f49aaba7c37c6571bbd8355349064e039012. Handoff описывает read-only study agent; live website acceptance pending, recovery/Calendar writes не включены. Исторический checkpoint 20.10 не считается новой приёмкой. Личные данные, credentials и resource identifiers исключены.</a:t>
             </a:r>
           </a:p>
         </p:txBody>
@@ -728,7 +728,7 @@
           <a:lstStyle xmlns:a="http://schemas.openxmlformats.org/drawingml/2006/main"/>
           <a:p xmlns:a="http://schemas.openxmlformats.org/drawingml/2006/main">
             <a:r>
-              <a:t>Инструменты и их mapping следуют README: solve_repair предоставляется как Function Calling, остальные перечисленные инструменты через MCP. MCP и Function Calling дополняют друг друга. Без отдельного backend-approved consent вызов apply_plan не разрешён. Архитектура и исторический облачный статус: README.md, setup/RECOVERY-WEB-HANDOFF.md, setup/RECOVERY-WEB-VALIDATION.md, setup/RECOVERY-ROLLOUT-2026-10-20.md из main 4a0858a00b3f1c1c2bf382981b0400f212f06fb8. Облачный checkpoint относится к 20.10.2026. Свежие локальные результаты ветки codex/pitch-ui-demo относятся к 21.10.2026 и описаны в LOCAL-VALIDATION.md. setup/PITCH-CLOUD-HANDOFF.md отсутствовал при подготовке. Персональные данные и private resource identifiers исключены.</a:t>
+              <a:t>Слайд отражает локальный реализованный сценарий и ограничения облачной приёмки. PDF/PNG/JPEG отправляются модели только по кнопке, распознанные пары требуют проверки и сохранения. Пары не экспортируются автоматически в Calendar. Recovery использует отдельное подтверждение версии и независимый verify. Новый read-only cloud study-agent не имеет инструментов записи. Локальные внешние сервисы синтетические, реальная модель OCR не тестировалась. Исходники UI: codex/pitch-ui-demo, база acf869b1eff2e50f2669c3f9f824b7b83cfb534d, 22.10.2026. Локальные проверки описаны в SCHEDULE-VALIDATION-2026-10-22.md. Облачный источник: setup/PITCH-CLOUD-HANDOFF.md из origin/codex/pitch-agent-cloud, SHA 1382f49aaba7c37c6571bbd8355349064e039012. Handoff описывает read-only study agent; live website acceptance pending, recovery/Calendar writes не включены. Исторический checkpoint 20.10 не считается новой приёмкой. Личные данные, credentials и resource identifiers исключены.</a:t>
             </a:r>
           </a:p>
         </p:txBody>
@@ -798,7 +798,7 @@
           <a:lstStyle xmlns:a="http://schemas.openxmlformats.org/drawingml/2006/main"/>
           <a:p xmlns:a="http://schemas.openxmlformats.org/drawingml/2006/main">
             <a:r>
-              <a:t>Cloud receipts исторические, 20.10.2026. В тот checkpoint реальный Engine async_query достиг service identity rejection boundary при синтетическом/неразрешённом вводе. Это подтверждает инфраструктурный путь и границы доступа, но не персональную successful tool execution. Per-user code ещё требовал обновления Engine/MCP, website recovery отключён. Credentials, account IDs, resource IDs and URLs исключены. Архитектура и исторический облачный статус: README.md, setup/RECOVERY-WEB-HANDOFF.md, setup/RECOVERY-WEB-VALIDATION.md, setup/RECOVERY-ROLLOUT-2026-10-20.md из main 4a0858a00b3f1c1c2bf382981b0400f212f06fb8. Облачный checkpoint относится к 20.10.2026. Свежие локальные результаты ветки codex/pitch-ui-demo относятся к 21.10.2026 и описаны в LOCAL-VALIDATION.md. setup/PITCH-CLOUD-HANDOFF.md отсутствовал при подготовке. Персональные данные и private resource identifiers исключены.</a:t>
+              <a:t>Слайд отражает локальный реализованный сценарий и ограничения облачной приёмки. PDF/PNG/JPEG отправляются модели только по кнопке, распознанные пары требуют проверки и сохранения. Пары не экспортируются автоматически в Calendar. Recovery использует отдельное подтверждение версии и независимый verify. Новый read-only cloud study-agent не имеет инструментов записи. Локальные внешние сервисы синтетические, реальная модель OCR не тестировалась. Исходники UI: codex/pitch-ui-demo, база acf869b1eff2e50f2669c3f9f824b7b83cfb534d, 22.10.2026. Локальные проверки описаны в SCHEDULE-VALIDATION-2026-10-22.md. Облачный источник: setup/PITCH-CLOUD-HANDOFF.md из origin/codex/pitch-agent-cloud, SHA 1382f49aaba7c37c6571bbd8355349064e039012. Handoff описывает read-only study agent; live website acceptance pending, recovery/Calendar writes не включены. Исторический checkpoint 20.10 не считается новой приёмкой. Личные данные, credentials и resource identifiers исключены.</a:t>
             </a:r>
           </a:p>
         </p:txBody>
@@ -868,7 +868,7 @@
           <a:lstStyle xmlns:a="http://schemas.openxmlformats.org/drawingml/2006/main"/>
           <a:p xmlns:a="http://schemas.openxmlformats.org/drawingml/2006/main">
             <a:r>
-              <a:t>Source: LOCAL-VALIDATION.md, fresh local verification 21.10.2026 in .venv-pitch. Full pytest: 2256 passed, 26 skipped, 35 warnings, 248.26 seconds. Missing environments: 12 Firestore Emulator tests and 14 PowerShell tests skipped. Separate recovery offline evaluation: 347 passed, 95 warnings. Voice literal-loopback: 53 passed. Wheel/sdist, pip check and MCP composition passed. Full local browser chain: effort90 and working window save/reload, proposal, exact consent, separate apply, verified, reload. Synthetic counters: 2 Calendar writes, apply_plan1, verify_plan1, 8 Calendar reads. Desktop/narrow layouts and console checked. Do not merge these counts or use them as a model quality measure. User acceptance with two real users and personal cloud test Calendars is still pending. Архитектура и исторический облачный статус: README.md, setup/RECOVERY-WEB-HANDOFF.md, setup/RECOVERY-WEB-VALIDATION.md, setup/RECOVERY-ROLLOUT-2026-10-20.md из main 4a0858a00b3f1c1c2bf382981b0400f212f06fb8. Облачный checkpoint относится к 20.10.2026. Свежие локальные результаты ветки codex/pitch-ui-demo относятся к 21.10.2026 и описаны в LOCAL-VALIDATION.md. setup/PITCH-CLOUD-HANDOFF.md отсутствовал при подготовке. Персональные данные и private resource identifiers исключены.</a:t>
+              <a:t>Слайд отражает локальный реализованный сценарий и ограничения облачной приёмки. PDF/PNG/JPEG отправляются модели только по кнопке, распознанные пары требуют проверки и сохранения. Пары не экспортируются автоматически в Calendar. Recovery использует отдельное подтверждение версии и независимый verify. Новый read-only cloud study-agent не имеет инструментов записи. Локальные внешние сервисы синтетические, реальная модель OCR не тестировалась. Исходники UI: codex/pitch-ui-demo, база acf869b1eff2e50f2669c3f9f824b7b83cfb534d, 22.10.2026. Локальные проверки описаны в SCHEDULE-VALIDATION-2026-10-22.md. Облачный источник: setup/PITCH-CLOUD-HANDOFF.md из origin/codex/pitch-agent-cloud, SHA 1382f49aaba7c37c6571bbd8355349064e039012. Handoff описывает read-only study agent; live website acceptance pending, recovery/Calendar writes не включены. Исторический checkpoint 20.10 не считается новой приёмкой. Личные данные, credentials и resource identifiers исключены.</a:t>
             </a:r>
           </a:p>
         </p:txBody>
@@ -915,7 +915,7 @@
           <p:cNvPr id="3" name="Title">
             <a:extLst xmlns:a="http://schemas.openxmlformats.org/drawingml/2006/main">
               <a:ext uri="{FF2B5EF4-FFF2-40B4-BE49-F238E27FC236}">
-                <a16:creationId xmlns:a16="http://schemas.microsoft.com/office/drawing/2014/main" id="{1E9BF8E4-F898-4EC7-B286-3A203E92D3E3}"/>
+                <a16:creationId xmlns:a16="http://schemas.microsoft.com/office/drawing/2014/main" id="{F4773ECA-21C3-4CF7-AC86-207C99E59CB9}"/>
               </a:ext>
             </a:extLst>
           </p:cNvPr>
@@ -1144,7 +1144,7 @@
           <p:cNvPr id="2" name="Subtitle">
             <a:extLst xmlns:a="http://schemas.openxmlformats.org/drawingml/2006/main">
               <a:ext uri="{FF2B5EF4-FFF2-40B4-BE49-F238E27FC236}">
-                <a16:creationId xmlns:a16="http://schemas.microsoft.com/office/drawing/2014/main" id="{F06D28D9-AD95-46DA-A3EC-B457F515E3CF}"/>
+                <a16:creationId xmlns:a16="http://schemas.microsoft.com/office/drawing/2014/main" id="{C11B72E1-1EEF-48A4-93FC-A10FD3992D10}"/>
               </a:ext>
             </a:extLst>
           </p:cNvPr>
@@ -1390,7 +1390,7 @@
           <p:cNvPr id="2" name="Section title">
             <a:extLst xmlns:a="http://schemas.openxmlformats.org/drawingml/2006/main">
               <a:ext uri="{FF2B5EF4-FFF2-40B4-BE49-F238E27FC236}">
-                <a16:creationId xmlns:a16="http://schemas.microsoft.com/office/drawing/2014/main" id="{89EC22A7-D4F5-4808-AFDD-BC9BF5720BD7}"/>
+                <a16:creationId xmlns:a16="http://schemas.microsoft.com/office/drawing/2014/main" id="{A05B60B5-2B83-4924-B0B5-FC0534F1378F}"/>
               </a:ext>
             </a:extLst>
           </p:cNvPr>
@@ -1636,7 +1636,7 @@
           <p:cNvPr id="3" name="Title">
             <a:extLst xmlns:a="http://schemas.openxmlformats.org/drawingml/2006/main">
               <a:ext uri="{FF2B5EF4-FFF2-40B4-BE49-F238E27FC236}">
-                <a16:creationId xmlns:a16="http://schemas.microsoft.com/office/drawing/2014/main" id="{7B66F1C5-EDA0-47BE-B08B-0752899017EF}"/>
+                <a16:creationId xmlns:a16="http://schemas.microsoft.com/office/drawing/2014/main" id="{DF8F464F-7D10-42EC-8EB8-0C441C32F1E6}"/>
               </a:ext>
             </a:extLst>
           </p:cNvPr>
@@ -1865,7 +1865,7 @@
           <p:cNvPr id="2" name="Body">
             <a:extLst xmlns:a="http://schemas.openxmlformats.org/drawingml/2006/main">
               <a:ext uri="{FF2B5EF4-FFF2-40B4-BE49-F238E27FC236}">
-                <a16:creationId xmlns:a16="http://schemas.microsoft.com/office/drawing/2014/main" id="{4CD99281-5BF4-434C-BB5B-ABC60182BCD3}"/>
+                <a16:creationId xmlns:a16="http://schemas.microsoft.com/office/drawing/2014/main" id="{0A5E131E-928E-4FAB-B7A8-42FAF130DC3D}"/>
               </a:ext>
             </a:extLst>
           </p:cNvPr>
@@ -2111,7 +2111,7 @@
           <p:cNvPr id="4" name="Title">
             <a:extLst xmlns:a="http://schemas.openxmlformats.org/drawingml/2006/main">
               <a:ext uri="{FF2B5EF4-FFF2-40B4-BE49-F238E27FC236}">
-                <a16:creationId xmlns:a16="http://schemas.microsoft.com/office/drawing/2014/main" id="{32F646DB-0571-4542-B2A7-1EB2943F06AB}"/>
+                <a16:creationId xmlns:a16="http://schemas.microsoft.com/office/drawing/2014/main" id="{A4AC1C46-1C3D-4477-AB61-C0ABC8DF1221}"/>
               </a:ext>
             </a:extLst>
           </p:cNvPr>
@@ -2340,7 +2340,7 @@
           <p:cNvPr id="2" name="Left column">
             <a:extLst xmlns:a="http://schemas.openxmlformats.org/drawingml/2006/main">
               <a:ext uri="{FF2B5EF4-FFF2-40B4-BE49-F238E27FC236}">
-                <a16:creationId xmlns:a16="http://schemas.microsoft.com/office/drawing/2014/main" id="{9C73781E-94F6-4BF1-B960-F34561725E35}"/>
+                <a16:creationId xmlns:a16="http://schemas.microsoft.com/office/drawing/2014/main" id="{C991C2C8-DFEE-4731-9696-DFF7A9D5DC25}"/>
               </a:ext>
             </a:extLst>
           </p:cNvPr>
@@ -2569,7 +2569,7 @@
           <p:cNvPr id="3" name="Right column">
             <a:extLst xmlns:a="http://schemas.openxmlformats.org/drawingml/2006/main">
               <a:ext uri="{FF2B5EF4-FFF2-40B4-BE49-F238E27FC236}">
-                <a16:creationId xmlns:a16="http://schemas.microsoft.com/office/drawing/2014/main" id="{47C8FA23-4821-48F2-B1D4-00A375A8CBFC}"/>
+                <a16:creationId xmlns:a16="http://schemas.microsoft.com/office/drawing/2014/main" id="{9DF03D9B-510B-40CA-8757-C0CCD374EC9B}"/>
               </a:ext>
             </a:extLst>
           </p:cNvPr>
@@ -2815,7 +2815,7 @@
           <p:cNvPr id="3" name="Title">
             <a:extLst xmlns:a="http://schemas.openxmlformats.org/drawingml/2006/main">
               <a:ext uri="{FF2B5EF4-FFF2-40B4-BE49-F238E27FC236}">
-                <a16:creationId xmlns:a16="http://schemas.microsoft.com/office/drawing/2014/main" id="{86F057E8-0A0A-4632-A14B-51FB5E4740EF}"/>
+                <a16:creationId xmlns:a16="http://schemas.microsoft.com/office/drawing/2014/main" id="{E6B74180-1175-4718-8C9E-7F2561F38392}"/>
               </a:ext>
             </a:extLst>
           </p:cNvPr>
@@ -3044,7 +3044,7 @@
           <p:cNvPr id="2" name="Left column">
             <a:extLst xmlns:a="http://schemas.openxmlformats.org/drawingml/2006/main">
               <a:ext uri="{FF2B5EF4-FFF2-40B4-BE49-F238E27FC236}">
-                <a16:creationId xmlns:a16="http://schemas.microsoft.com/office/drawing/2014/main" id="{C21BFAAF-907A-40E3-90BF-67A4D4B12B29}"/>
+                <a16:creationId xmlns:a16="http://schemas.microsoft.com/office/drawing/2014/main" id="{D694738A-01A8-487B-B815-517C9F31BF75}"/>
               </a:ext>
             </a:extLst>
           </p:cNvPr>
@@ -3311,12 +3311,12 @@
   </p:cSld>
   <p:clrMap bg1="lt1" tx1="dk1" bg2="lt2" tx2="dk2" accent1="accent1" accent2="accent2" accent3="accent3" accent4="accent4" accent5="accent5" accent6="accent6" hlink="hlink" folHlink="folHlink"/>
   <p:sldLayoutIdLst>
-    <p:sldLayoutId xmlns:r="http://schemas.openxmlformats.org/officeDocument/2006/relationships" id="2147483649" r:id="R628e45dee50249e5"/>
-    <p:sldLayoutId xmlns:r="http://schemas.openxmlformats.org/officeDocument/2006/relationships" id="2147483650" r:id="R72a7e62f329e490b"/>
-    <p:sldLayoutId xmlns:r="http://schemas.openxmlformats.org/officeDocument/2006/relationships" id="2147483651" r:id="Rfcbd05fa42454670"/>
-    <p:sldLayoutId xmlns:r="http://schemas.openxmlformats.org/officeDocument/2006/relationships" id="2147483652" r:id="R4eb4e52a34c14c87"/>
-    <p:sldLayoutId xmlns:r="http://schemas.openxmlformats.org/officeDocument/2006/relationships" id="2147483653" r:id="R78855232f77b4704"/>
-    <p:sldLayoutId xmlns:r="http://schemas.openxmlformats.org/officeDocument/2006/relationships" id="2147483654" r:id="R0981ab0b77904ae9"/>
+    <p:sldLayoutId xmlns:r="http://schemas.openxmlformats.org/officeDocument/2006/relationships" id="2147483649" r:id="Re7bf4bb880f74f08"/>
+    <p:sldLayoutId xmlns:r="http://schemas.openxmlformats.org/officeDocument/2006/relationships" id="2147483650" r:id="R2806a4c4a1824368"/>
+    <p:sldLayoutId xmlns:r="http://schemas.openxmlformats.org/officeDocument/2006/relationships" id="2147483651" r:id="R302be27098584332"/>
+    <p:sldLayoutId xmlns:r="http://schemas.openxmlformats.org/officeDocument/2006/relationships" id="2147483652" r:id="Rcdab0370fc044d78"/>
+    <p:sldLayoutId xmlns:r="http://schemas.openxmlformats.org/officeDocument/2006/relationships" id="2147483653" r:id="Rd80e8cbf69964578"/>
+    <p:sldLayoutId xmlns:r="http://schemas.openxmlformats.org/officeDocument/2006/relationships" id="2147483654" r:id="R2411adcfa4c744ba"/>
   </p:sldLayoutIdLst>
   <p:txStyles>
     <p:titleStyle>
@@ -3867,7 +3867,7 @@
           <p:cNvPr id="11" name="">
             <a:extLst xmlns:a="http://schemas.openxmlformats.org/drawingml/2006/main">
               <a:ext uri="{FF2B5EF4-FFF2-40B4-BE49-F238E27FC236}">
-                <a16:creationId xmlns:a16="http://schemas.microsoft.com/office/drawing/2014/main" id="{A43B0125-6B71-4256-B879-EF474ABE8E25}"/>
+                <a16:creationId xmlns:a16="http://schemas.microsoft.com/office/drawing/2014/main" id="{82F5F2A2-D676-4913-888D-37010B144663}"/>
               </a:ext>
             </a:extLst>
           </p:cNvPr>
@@ -4025,7 +4025,7 @@
           <p:cNvPr id="2" name="">
             <a:extLst xmlns:a="http://schemas.openxmlformats.org/drawingml/2006/main">
               <a:ext uri="{FF2B5EF4-FFF2-40B4-BE49-F238E27FC236}">
-                <a16:creationId xmlns:a16="http://schemas.microsoft.com/office/drawing/2014/main" id="{5CD121E9-960D-4D56-B529-5D5198A12913}"/>
+                <a16:creationId xmlns:a16="http://schemas.microsoft.com/office/drawing/2014/main" id="{0A618521-7861-47DA-AB8B-5BE9F0861101}"/>
               </a:ext>
             </a:extLst>
           </p:cNvPr>
@@ -4183,7 +4183,7 @@
           <p:cNvPr id="3" name="">
             <a:extLst xmlns:a="http://schemas.openxmlformats.org/drawingml/2006/main">
               <a:ext uri="{FF2B5EF4-FFF2-40B4-BE49-F238E27FC236}">
-                <a16:creationId xmlns:a16="http://schemas.microsoft.com/office/drawing/2014/main" id="{44F80619-776F-403A-B69C-86691E9082B0}"/>
+                <a16:creationId xmlns:a16="http://schemas.microsoft.com/office/drawing/2014/main" id="{3A72D2BC-9A66-4D41-AAC9-97CF4044FC67}"/>
               </a:ext>
             </a:extLst>
           </p:cNvPr>
@@ -4341,7 +4341,7 @@
           <p:cNvPr id="4" name="">
             <a:extLst xmlns:a="http://schemas.openxmlformats.org/drawingml/2006/main">
               <a:ext uri="{FF2B5EF4-FFF2-40B4-BE49-F238E27FC236}">
-                <a16:creationId xmlns:a16="http://schemas.microsoft.com/office/drawing/2014/main" id="{F25F7F55-1614-4F42-B327-12D1DCC8AB85}"/>
+                <a16:creationId xmlns:a16="http://schemas.microsoft.com/office/drawing/2014/main" id="{6F3BF573-16D2-4C41-B613-B2FC6064DAB3}"/>
               </a:ext>
             </a:extLst>
           </p:cNvPr>
@@ -4499,7 +4499,7 @@
           <p:cNvPr id="5" name="">
             <a:extLst xmlns:a="http://schemas.openxmlformats.org/drawingml/2006/main">
               <a:ext uri="{FF2B5EF4-FFF2-40B4-BE49-F238E27FC236}">
-                <a16:creationId xmlns:a16="http://schemas.microsoft.com/office/drawing/2014/main" id="{C36B8ED5-DE44-412E-9A3E-D28ED75E9919}"/>
+                <a16:creationId xmlns:a16="http://schemas.microsoft.com/office/drawing/2014/main" id="{932E5F77-886C-4829-B7AB-41869A7CB590}"/>
               </a:ext>
             </a:extLst>
           </p:cNvPr>
@@ -4529,7 +4529,7 @@
           <p:cNvPr id="6" name="">
             <a:extLst xmlns:a="http://schemas.openxmlformats.org/drawingml/2006/main">
               <a:ext uri="{FF2B5EF4-FFF2-40B4-BE49-F238E27FC236}">
-                <a16:creationId xmlns:a16="http://schemas.microsoft.com/office/drawing/2014/main" id="{1E354FEF-A617-4974-B4B9-ED2A5F6A2723}"/>
+                <a16:creationId xmlns:a16="http://schemas.microsoft.com/office/drawing/2014/main" id="{3D877267-C787-4162-89D0-91BC264C6957}"/>
               </a:ext>
             </a:extLst>
           </p:cNvPr>
@@ -4687,7 +4687,7 @@
           <p:cNvPr id="7" name="">
             <a:extLst xmlns:a="http://schemas.openxmlformats.org/drawingml/2006/main">
               <a:ext uri="{FF2B5EF4-FFF2-40B4-BE49-F238E27FC236}">
-                <a16:creationId xmlns:a16="http://schemas.microsoft.com/office/drawing/2014/main" id="{786D8988-9369-4D89-B2DA-0EE6F1114C25}"/>
+                <a16:creationId xmlns:a16="http://schemas.microsoft.com/office/drawing/2014/main" id="{EE7DA52D-2D16-4712-9C88-B78A9B237EF9}"/>
               </a:ext>
             </a:extLst>
           </p:cNvPr>
@@ -4868,7 +4868,7 @@
           <p:cNvPr id="8" name="">
             <a:extLst xmlns:a="http://schemas.openxmlformats.org/drawingml/2006/main">
               <a:ext uri="{FF2B5EF4-FFF2-40B4-BE49-F238E27FC236}">
-                <a16:creationId xmlns:a16="http://schemas.microsoft.com/office/drawing/2014/main" id="{6A71F5C1-F26B-44E8-BAEA-D0DCCBE4A0A1}"/>
+                <a16:creationId xmlns:a16="http://schemas.microsoft.com/office/drawing/2014/main" id="{CF2471B2-B3B2-43D8-B9B4-C79168675A34}"/>
               </a:ext>
             </a:extLst>
           </p:cNvPr>
@@ -5026,7 +5026,7 @@
           <p:cNvPr id="9" name="">
             <a:extLst xmlns:a="http://schemas.openxmlformats.org/drawingml/2006/main">
               <a:ext uri="{FF2B5EF4-FFF2-40B4-BE49-F238E27FC236}">
-                <a16:creationId xmlns:a16="http://schemas.microsoft.com/office/drawing/2014/main" id="{435C467F-32AE-4F0C-9966-5EA07E64C865}"/>
+                <a16:creationId xmlns:a16="http://schemas.microsoft.com/office/drawing/2014/main" id="{873C4114-A07A-4510-9ACF-D3D8527C8F95}"/>
               </a:ext>
             </a:extLst>
           </p:cNvPr>
@@ -5230,7 +5230,7 @@
           <p:cNvPr id="10" name="">
             <a:extLst xmlns:a="http://schemas.openxmlformats.org/drawingml/2006/main">
               <a:ext uri="{FF2B5EF4-FFF2-40B4-BE49-F238E27FC236}">
-                <a16:creationId xmlns:a16="http://schemas.microsoft.com/office/drawing/2014/main" id="{CFD6B06D-6C60-4E59-9741-A7F92DB7D120}"/>
+                <a16:creationId xmlns:a16="http://schemas.microsoft.com/office/drawing/2014/main" id="{23AEB673-94EB-421A-9BB9-D0D66CE9BC98}"/>
               </a:ext>
             </a:extLst>
           </p:cNvPr>
@@ -5386,7 +5386,7 @@
     </p:spTree>
     <p:extLst>
       <p:ext uri="{BB962C8B-B14F-4D97-AF65-F5344CB8AC3E}">
-        <p14:creationId xmlns:p14="http://schemas.microsoft.com/office/powerpoint/2010/main" val="247504265"/>
+        <p14:creationId xmlns:p14="http://schemas.microsoft.com/office/powerpoint/2010/main" val="1615903009"/>
       </p:ext>
     </p:extLst>
   </p:cSld>
@@ -5417,7 +5417,7 @@
           <p:cNvPr id="12" name="">
             <a:extLst xmlns:a="http://schemas.openxmlformats.org/drawingml/2006/main">
               <a:ext uri="{FF2B5EF4-FFF2-40B4-BE49-F238E27FC236}">
-                <a16:creationId xmlns:a16="http://schemas.microsoft.com/office/drawing/2014/main" id="{437FC19D-4411-4982-BC78-2B6395F8DEE2}"/>
+                <a16:creationId xmlns:a16="http://schemas.microsoft.com/office/drawing/2014/main" id="{CCA400C9-5612-4A79-AF97-2B972B5319C6}"/>
               </a:ext>
             </a:extLst>
           </p:cNvPr>
@@ -5575,7 +5575,7 @@
           <p:cNvPr id="2" name="">
             <a:extLst xmlns:a="http://schemas.openxmlformats.org/drawingml/2006/main">
               <a:ext uri="{FF2B5EF4-FFF2-40B4-BE49-F238E27FC236}">
-                <a16:creationId xmlns:a16="http://schemas.microsoft.com/office/drawing/2014/main" id="{BB178E55-AE4D-4242-8AD5-5EB635BE4001}"/>
+                <a16:creationId xmlns:a16="http://schemas.microsoft.com/office/drawing/2014/main" id="{C14575A9-E831-452F-BDAD-BEFD2586A49B}"/>
               </a:ext>
             </a:extLst>
           </p:cNvPr>
@@ -5733,7 +5733,7 @@
           <p:cNvPr id="3" name="">
             <a:extLst xmlns:a="http://schemas.openxmlformats.org/drawingml/2006/main">
               <a:ext uri="{FF2B5EF4-FFF2-40B4-BE49-F238E27FC236}">
-                <a16:creationId xmlns:a16="http://schemas.microsoft.com/office/drawing/2014/main" id="{1914E941-DDBE-4E69-817D-D396B3CA4979}"/>
+                <a16:creationId xmlns:a16="http://schemas.microsoft.com/office/drawing/2014/main" id="{070909BC-D38D-47F7-8B60-34F7688AD679}"/>
               </a:ext>
             </a:extLst>
           </p:cNvPr>
@@ -5891,7 +5891,7 @@
           <p:cNvPr id="4" name="">
             <a:extLst xmlns:a="http://schemas.openxmlformats.org/drawingml/2006/main">
               <a:ext uri="{FF2B5EF4-FFF2-40B4-BE49-F238E27FC236}">
-                <a16:creationId xmlns:a16="http://schemas.microsoft.com/office/drawing/2014/main" id="{FABE589D-0995-4ADC-A25B-9010A789CBAC}"/>
+                <a16:creationId xmlns:a16="http://schemas.microsoft.com/office/drawing/2014/main" id="{06068796-5C73-41FC-A6F6-CBA7CA1CCF6A}"/>
               </a:ext>
             </a:extLst>
           </p:cNvPr>
@@ -6049,7 +6049,7 @@
           <p:cNvPr id="5" name="">
             <a:extLst xmlns:a="http://schemas.openxmlformats.org/drawingml/2006/main">
               <a:ext uri="{FF2B5EF4-FFF2-40B4-BE49-F238E27FC236}">
-                <a16:creationId xmlns:a16="http://schemas.microsoft.com/office/drawing/2014/main" id="{B4C7AE57-A5BA-4825-889B-B849DD8449D8}"/>
+                <a16:creationId xmlns:a16="http://schemas.microsoft.com/office/drawing/2014/main" id="{46085491-386E-4616-8E21-25F79A1FACDF}"/>
               </a:ext>
             </a:extLst>
           </p:cNvPr>
@@ -6079,7 +6079,7 @@
           <p:cNvPr id="6" name="">
             <a:extLst xmlns:a="http://schemas.openxmlformats.org/drawingml/2006/main">
               <a:ext uri="{FF2B5EF4-FFF2-40B4-BE49-F238E27FC236}">
-                <a16:creationId xmlns:a16="http://schemas.microsoft.com/office/drawing/2014/main" id="{255C83E1-5637-49D6-A6DC-B7A8125FF198}"/>
+                <a16:creationId xmlns:a16="http://schemas.microsoft.com/office/drawing/2014/main" id="{42562B90-413E-4695-97FD-2C740BAC30C2}"/>
               </a:ext>
             </a:extLst>
           </p:cNvPr>
@@ -6237,7 +6237,7 @@
           <p:cNvPr id="7" name="">
             <a:extLst xmlns:a="http://schemas.openxmlformats.org/drawingml/2006/main">
               <a:ext uri="{FF2B5EF4-FFF2-40B4-BE49-F238E27FC236}">
-                <a16:creationId xmlns:a16="http://schemas.microsoft.com/office/drawing/2014/main" id="{C404CD6F-3CD2-47BE-ADD4-E764CD69B33B}"/>
+                <a16:creationId xmlns:a16="http://schemas.microsoft.com/office/drawing/2014/main" id="{0F106F66-EDFC-472E-A595-DDB72DA50D73}"/>
               </a:ext>
             </a:extLst>
           </p:cNvPr>
@@ -6385,7 +6385,7 @@
                 <a:ea typeface="Helvetica Neue"/>
                 <a:cs typeface="Helvetica Neue"/>
               </a:rPr>
-              <a:t>Опубликованное приложение</a:t>
+              <a:t>Данные студента</a:t>
             </a:r>
           </a:p>
         </p:txBody>
@@ -6395,7 +6395,7 @@
           <p:cNvPr id="8" name="">
             <a:extLst xmlns:a="http://schemas.openxmlformats.org/drawingml/2006/main">
               <a:ext uri="{FF2B5EF4-FFF2-40B4-BE49-F238E27FC236}">
-                <a16:creationId xmlns:a16="http://schemas.microsoft.com/office/drawing/2014/main" id="{1911C275-5313-4D61-BE98-E48629AB1B16}"/>
+                <a16:creationId xmlns:a16="http://schemas.microsoft.com/office/drawing/2014/main" id="{B259229B-0463-4008-8FB6-8DEC4AAD86F5}"/>
               </a:ext>
             </a:extLst>
           </p:cNvPr>
@@ -6543,7 +6543,7 @@
                 <a:ea typeface="Helvetica Neue"/>
                 <a:cs typeface="Helvetica Neue"/>
               </a:rPr>
-              <a:t>Google-вход и Moodle iCalendar</a:t>
+              <a:t>Дедлайны Moodle</a:t>
             </a:r>
           </a:p>
           <a:p xmlns:a="http://schemas.openxmlformats.org/drawingml/2006/main">
@@ -6566,7 +6566,7 @@
                 <a:ea typeface="Helvetica Neue"/>
                 <a:cs typeface="Helvetica Neue"/>
               </a:rPr>
-              <a:t>Диалог с Gemini по дедлайнам</a:t>
+              <a:t>Пары из PDF или скриншота</a:t>
             </a:r>
           </a:p>
           <a:p xmlns:a="http://schemas.openxmlformats.org/drawingml/2006/main">
@@ -6589,7 +6589,7 @@
                 <a:ea typeface="Helvetica Neue"/>
                 <a:cs typeface="Helvetica Neue"/>
               </a:rPr>
-              <a:t>Ручное расписание и Firestore</a:t>
+              <a:t>Минуты на задания и свободные окна</a:t>
             </a:r>
           </a:p>
         </p:txBody>
@@ -6599,7 +6599,7 @@
           <p:cNvPr id="9" name="">
             <a:extLst xmlns:a="http://schemas.openxmlformats.org/drawingml/2006/main">
               <a:ext uri="{FF2B5EF4-FFF2-40B4-BE49-F238E27FC236}">
-                <a16:creationId xmlns:a16="http://schemas.microsoft.com/office/drawing/2014/main" id="{89049A4F-AE56-47A4-BAF7-E37641D3CDB5}"/>
+                <a16:creationId xmlns:a16="http://schemas.microsoft.com/office/drawing/2014/main" id="{BFCF8641-0783-4C35-B939-51D6316B51AB}"/>
               </a:ext>
             </a:extLst>
           </p:cNvPr>
@@ -6747,7 +6747,7 @@
                 <a:ea typeface="Helvetica Neue"/>
                 <a:cs typeface="Helvetica Neue"/>
               </a:rPr>
-              <a:t>Recovery-процесс в коде</a:t>
+              <a:t>Понятный результат</a:t>
             </a:r>
           </a:p>
         </p:txBody>
@@ -6757,7 +6757,7 @@
           <p:cNvPr id="10" name="">
             <a:extLst xmlns:a="http://schemas.openxmlformats.org/drawingml/2006/main">
               <a:ext uri="{FF2B5EF4-FFF2-40B4-BE49-F238E27FC236}">
-                <a16:creationId xmlns:a16="http://schemas.microsoft.com/office/drawing/2014/main" id="{4A0B9FBB-59C8-4F16-9770-B5A9773FF6F3}"/>
+                <a16:creationId xmlns:a16="http://schemas.microsoft.com/office/drawing/2014/main" id="{60BEB169-B7F8-425C-B0AF-8EFDFAE336C6}"/>
               </a:ext>
             </a:extLst>
           </p:cNvPr>
@@ -6905,7 +6905,7 @@
                 <a:ea typeface="Helvetica Neue"/>
                 <a:cs typeface="Helvetica Neue"/>
               </a:rPr>
-              <a:t>Предложение на 72 часа</a:t>
+              <a:t>Предложенное расписание на 72 часа</a:t>
             </a:r>
           </a:p>
           <a:p xmlns:a="http://schemas.openxmlformats.org/drawingml/2006/main">
@@ -6928,7 +6928,7 @@
                 <a:ea typeface="Helvetica Neue"/>
                 <a:cs typeface="Helvetica Neue"/>
               </a:rPr>
-              <a:t>Согласие на точный план</a:t>
+              <a:t>Подтверждение точной версии</a:t>
             </a:r>
           </a:p>
           <a:p xmlns:a="http://schemas.openxmlformats.org/drawingml/2006/main">
@@ -6951,7 +6951,7 @@
                 <a:ea typeface="Helvetica Neue"/>
                 <a:cs typeface="Helvetica Neue"/>
               </a:rPr>
-              <a:t>Применение и независимый verify</a:t>
+              <a:t>Calendar и независимая проверка</a:t>
             </a:r>
           </a:p>
         </p:txBody>
@@ -6961,7 +6961,7 @@
           <p:cNvPr id="11" name="">
             <a:extLst xmlns:a="http://schemas.openxmlformats.org/drawingml/2006/main">
               <a:ext uri="{FF2B5EF4-FFF2-40B4-BE49-F238E27FC236}">
-                <a16:creationId xmlns:a16="http://schemas.microsoft.com/office/drawing/2014/main" id="{9A32F080-A16C-4E5C-8D60-9490F1B9D158}"/>
+                <a16:creationId xmlns:a16="http://schemas.microsoft.com/office/drawing/2014/main" id="{2D7E06F5-AFBF-47DD-905A-EAC09F70BF94}"/>
               </a:ext>
             </a:extLst>
           </p:cNvPr>
@@ -7109,7 +7109,7 @@
                 <a:ea typeface="Helvetica Neue"/>
                 <a:cs typeface="Helvetica Neue"/>
               </a:rPr>
-              <a:t>По checkpoint 20.10 персональный recovery на сайте выключен.</a:t>
+              <a:t>Новый UI проверен локально. Полный облачный цикл не подтверждён.</a:t>
             </a:r>
           </a:p>
         </p:txBody>
@@ -7117,7 +7117,7 @@
     </p:spTree>
     <p:extLst>
       <p:ext uri="{BB962C8B-B14F-4D97-AF65-F5344CB8AC3E}">
-        <p14:creationId xmlns:p14="http://schemas.microsoft.com/office/powerpoint/2010/main" val="136377983"/>
+        <p14:creationId xmlns:p14="http://schemas.microsoft.com/office/powerpoint/2010/main" val="1002971790"/>
       </p:ext>
     </p:extLst>
   </p:cSld>
@@ -7148,7 +7148,7 @@
           <p:cNvPr id="15" name="">
             <a:extLst xmlns:a="http://schemas.openxmlformats.org/drawingml/2006/main">
               <a:ext uri="{FF2B5EF4-FFF2-40B4-BE49-F238E27FC236}">
-                <a16:creationId xmlns:a16="http://schemas.microsoft.com/office/drawing/2014/main" id="{21BA6087-A97E-469F-881C-5C35F673B350}"/>
+                <a16:creationId xmlns:a16="http://schemas.microsoft.com/office/drawing/2014/main" id="{D233C202-1F78-4D87-AFD4-DECC4946D628}"/>
               </a:ext>
             </a:extLst>
           </p:cNvPr>
@@ -7180,7 +7180,7 @@
           <p:cNvPr id="14" name="">
             <a:extLst xmlns:a="http://schemas.openxmlformats.org/drawingml/2006/main">
               <a:ext uri="{FF2B5EF4-FFF2-40B4-BE49-F238E27FC236}">
-                <a16:creationId xmlns:a16="http://schemas.microsoft.com/office/drawing/2014/main" id="{CA0730FA-B4C8-431A-A68C-734543ABE1E1}"/>
+                <a16:creationId xmlns:a16="http://schemas.microsoft.com/office/drawing/2014/main" id="{0DC9EA35-D8FB-4D21-9BEB-45C3B8951414}"/>
               </a:ext>
             </a:extLst>
           </p:cNvPr>
@@ -7212,7 +7212,7 @@
           <p:cNvPr id="13" name="">
             <a:extLst xmlns:a="http://schemas.openxmlformats.org/drawingml/2006/main">
               <a:ext uri="{FF2B5EF4-FFF2-40B4-BE49-F238E27FC236}">
-                <a16:creationId xmlns:a16="http://schemas.microsoft.com/office/drawing/2014/main" id="{46B396C2-6E40-4BB7-8145-8D5331F994D9}"/>
+                <a16:creationId xmlns:a16="http://schemas.microsoft.com/office/drawing/2014/main" id="{0F5DFD5B-CFC3-4AA7-8108-CDE5D675A4C8}"/>
               </a:ext>
             </a:extLst>
           </p:cNvPr>
@@ -7244,7 +7244,7 @@
           <p:cNvPr id="12" name="">
             <a:extLst xmlns:a="http://schemas.openxmlformats.org/drawingml/2006/main">
               <a:ext uri="{FF2B5EF4-FFF2-40B4-BE49-F238E27FC236}">
-                <a16:creationId xmlns:a16="http://schemas.microsoft.com/office/drawing/2014/main" id="{292C4787-1860-4066-8766-E062757548E1}"/>
+                <a16:creationId xmlns:a16="http://schemas.microsoft.com/office/drawing/2014/main" id="{0FDE7B87-2192-4BA3-AA37-9F9AA9B4289C}"/>
               </a:ext>
             </a:extLst>
           </p:cNvPr>
@@ -7276,7 +7276,7 @@
           <p:cNvPr id="18" name="">
             <a:extLst xmlns:a="http://schemas.openxmlformats.org/drawingml/2006/main">
               <a:ext uri="{FF2B5EF4-FFF2-40B4-BE49-F238E27FC236}">
-                <a16:creationId xmlns:a16="http://schemas.microsoft.com/office/drawing/2014/main" id="{68140F4D-7E1B-4740-A29B-0CC078765781}"/>
+                <a16:creationId xmlns:a16="http://schemas.microsoft.com/office/drawing/2014/main" id="{54D26859-055D-483A-BE0D-16BE2A455F6C}"/>
               </a:ext>
             </a:extLst>
           </p:cNvPr>
@@ -7434,7 +7434,7 @@
           <p:cNvPr id="2" name="">
             <a:extLst xmlns:a="http://schemas.openxmlformats.org/drawingml/2006/main">
               <a:ext uri="{FF2B5EF4-FFF2-40B4-BE49-F238E27FC236}">
-                <a16:creationId xmlns:a16="http://schemas.microsoft.com/office/drawing/2014/main" id="{66D7D66A-CA23-4F54-8A6E-9CDEAE6CB6E0}"/>
+                <a16:creationId xmlns:a16="http://schemas.microsoft.com/office/drawing/2014/main" id="{50EFD60E-DF18-42D8-AB65-95CC8BA05D38}"/>
               </a:ext>
             </a:extLst>
           </p:cNvPr>
@@ -7592,7 +7592,7 @@
           <p:cNvPr id="3" name="">
             <a:extLst xmlns:a="http://schemas.openxmlformats.org/drawingml/2006/main">
               <a:ext uri="{FF2B5EF4-FFF2-40B4-BE49-F238E27FC236}">
-                <a16:creationId xmlns:a16="http://schemas.microsoft.com/office/drawing/2014/main" id="{9AB8C0AD-E178-4AC6-939A-196ECAB4F776}"/>
+                <a16:creationId xmlns:a16="http://schemas.microsoft.com/office/drawing/2014/main" id="{FF2A8307-07BF-4028-A164-B10CB66AC852}"/>
               </a:ext>
             </a:extLst>
           </p:cNvPr>
@@ -7750,7 +7750,7 @@
           <p:cNvPr id="4" name="">
             <a:extLst xmlns:a="http://schemas.openxmlformats.org/drawingml/2006/main">
               <a:ext uri="{FF2B5EF4-FFF2-40B4-BE49-F238E27FC236}">
-                <a16:creationId xmlns:a16="http://schemas.microsoft.com/office/drawing/2014/main" id="{DCF045BB-63BB-4FD7-82AD-965DF4AA9E4D}"/>
+                <a16:creationId xmlns:a16="http://schemas.microsoft.com/office/drawing/2014/main" id="{A27ADD33-4258-403B-8D00-F7EFCAC149C9}"/>
               </a:ext>
             </a:extLst>
           </p:cNvPr>
@@ -7898,7 +7898,7 @@
                 <a:ea typeface="Helvetica Neue"/>
                 <a:cs typeface="Helvetica Neue"/>
               </a:rPr>
-              <a:t>Студент задаёт свободное время и оставшуюся трудоёмкость заданий</a:t>
+              <a:t>Сначала студент проверяет распознанные пары, затем сохраняет время для заданий</a:t>
             </a:r>
           </a:p>
         </p:txBody>
@@ -7908,7 +7908,7 @@
           <p:cNvPr id="5" name="">
             <a:extLst xmlns:a="http://schemas.openxmlformats.org/drawingml/2006/main">
               <a:ext uri="{FF2B5EF4-FFF2-40B4-BE49-F238E27FC236}">
-                <a16:creationId xmlns:a16="http://schemas.microsoft.com/office/drawing/2014/main" id="{598961D1-F241-429C-BAAD-F412D4A0A79D}"/>
+                <a16:creationId xmlns:a16="http://schemas.microsoft.com/office/drawing/2014/main" id="{DE232A68-53DE-444E-84D4-1EF51A3E55B2}"/>
               </a:ext>
             </a:extLst>
           </p:cNvPr>
@@ -7938,7 +7938,7 @@
           <p:cNvPr id="6" name="">
             <a:extLst xmlns:a="http://schemas.openxmlformats.org/drawingml/2006/main">
               <a:ext uri="{FF2B5EF4-FFF2-40B4-BE49-F238E27FC236}">
-                <a16:creationId xmlns:a16="http://schemas.microsoft.com/office/drawing/2014/main" id="{171A1A5D-0EA3-4DDC-BA94-33E896A70D05}"/>
+                <a16:creationId xmlns:a16="http://schemas.microsoft.com/office/drawing/2014/main" id="{DE6F8227-1B64-454C-8E40-A2DB51F103C9}"/>
               </a:ext>
             </a:extLst>
           </p:cNvPr>
@@ -8096,7 +8096,7 @@
           <p:cNvPr id="7" name="">
             <a:extLst xmlns:a="http://schemas.openxmlformats.org/drawingml/2006/main">
               <a:ext uri="{FF2B5EF4-FFF2-40B4-BE49-F238E27FC236}">
-                <a16:creationId xmlns:a16="http://schemas.microsoft.com/office/drawing/2014/main" id="{B4AC3334-B124-4DB7-A8E5-AA7EDF987808}"/>
+                <a16:creationId xmlns:a16="http://schemas.microsoft.com/office/drawing/2014/main" id="{401FFA93-EDDC-41AC-B0B0-468DE00965FC}"/>
               </a:ext>
             </a:extLst>
           </p:cNvPr>
@@ -8271,7 +8271,7 @@
                 <a:ea typeface="Helvetica Neue"/>
                 <a:cs typeface="Helvetica Neue"/>
               </a:rPr>
-              <a:t>Чтение</a:t>
+              <a:t>Moodle +</a:t>
             </a:r>
           </a:p>
           <a:p xmlns:a="http://schemas.openxmlformats.org/drawingml/2006/main">
@@ -8294,7 +8294,7 @@
                 <a:ea typeface="Helvetica Neue"/>
                 <a:cs typeface="Helvetica Neue"/>
               </a:rPr>
-              <a:t>источников</a:t>
+              <a:t>пары</a:t>
             </a:r>
           </a:p>
         </p:txBody>
@@ -8304,7 +8304,7 @@
           <p:cNvPr id="8" name="">
             <a:extLst xmlns:a="http://schemas.openxmlformats.org/drawingml/2006/main">
               <a:ext uri="{FF2B5EF4-FFF2-40B4-BE49-F238E27FC236}">
-                <a16:creationId xmlns:a16="http://schemas.microsoft.com/office/drawing/2014/main" id="{4D4FC88F-048E-4D5A-B3B9-EB48AA5B9C41}"/>
+                <a16:creationId xmlns:a16="http://schemas.microsoft.com/office/drawing/2014/main" id="{7C6BC88B-44B7-433E-AE5A-B8B8C0AC6232}"/>
               </a:ext>
             </a:extLst>
           </p:cNvPr>
@@ -8479,7 +8479,7 @@
                 <a:ea typeface="Helvetica Neue"/>
                 <a:cs typeface="Helvetica Neue"/>
               </a:rPr>
-              <a:t>Расчёт</a:t>
+              <a:t>Предложенное</a:t>
             </a:r>
           </a:p>
           <a:p xmlns:a="http://schemas.openxmlformats.org/drawingml/2006/main">
@@ -8502,7 +8502,7 @@
                 <a:ea typeface="Helvetica Neue"/>
                 <a:cs typeface="Helvetica Neue"/>
               </a:rPr>
-              <a:t>предложения</a:t>
+              <a:t>расписание</a:t>
             </a:r>
           </a:p>
         </p:txBody>
@@ -8512,7 +8512,7 @@
           <p:cNvPr id="9" name="">
             <a:extLst xmlns:a="http://schemas.openxmlformats.org/drawingml/2006/main">
               <a:ext uri="{FF2B5EF4-FFF2-40B4-BE49-F238E27FC236}">
-                <a16:creationId xmlns:a16="http://schemas.microsoft.com/office/drawing/2014/main" id="{F732E228-D79D-4F1D-B0CD-3F18CC3F46A2}"/>
+                <a16:creationId xmlns:a16="http://schemas.microsoft.com/office/drawing/2014/main" id="{D5F0E351-8538-4ED2-994A-6555684FE870}"/>
               </a:ext>
             </a:extLst>
           </p:cNvPr>
@@ -8687,7 +8687,7 @@
                 <a:ea typeface="Helvetica Neue"/>
                 <a:cs typeface="Helvetica Neue"/>
               </a:rPr>
-              <a:t>Согласие</a:t>
+              <a:t>Подтвердить</a:t>
             </a:r>
           </a:p>
           <a:p xmlns:a="http://schemas.openxmlformats.org/drawingml/2006/main">
@@ -8710,7 +8710,7 @@
                 <a:ea typeface="Helvetica Neue"/>
                 <a:cs typeface="Helvetica Neue"/>
               </a:rPr>
-              <a:t>на план</a:t>
+              <a:t>версию</a:t>
             </a:r>
           </a:p>
         </p:txBody>
@@ -8720,7 +8720,7 @@
           <p:cNvPr id="10" name="">
             <a:extLst xmlns:a="http://schemas.openxmlformats.org/drawingml/2006/main">
               <a:ext uri="{FF2B5EF4-FFF2-40B4-BE49-F238E27FC236}">
-                <a16:creationId xmlns:a16="http://schemas.microsoft.com/office/drawing/2014/main" id="{40EFB7EB-81BB-4B4E-B127-4D8F28F62775}"/>
+                <a16:creationId xmlns:a16="http://schemas.microsoft.com/office/drawing/2014/main" id="{94F2DC69-1C7C-4BB7-964C-A0B95A32C8E9}"/>
               </a:ext>
             </a:extLst>
           </p:cNvPr>
@@ -8928,7 +8928,7 @@
           <p:cNvPr id="11" name="">
             <a:extLst xmlns:a="http://schemas.openxmlformats.org/drawingml/2006/main">
               <a:ext uri="{FF2B5EF4-FFF2-40B4-BE49-F238E27FC236}">
-                <a16:creationId xmlns:a16="http://schemas.microsoft.com/office/drawing/2014/main" id="{3F9ACF78-590A-431E-B544-57B102BE7C40}"/>
+                <a16:creationId xmlns:a16="http://schemas.microsoft.com/office/drawing/2014/main" id="{0FA2ED85-5DE7-47FE-ABE7-82A965BDCD9E}"/>
               </a:ext>
             </a:extLst>
           </p:cNvPr>
@@ -9103,7 +9103,7 @@
                 <a:ea typeface="Helvetica Neue"/>
                 <a:cs typeface="Helvetica Neue"/>
               </a:rPr>
-              <a:t>Независимый</a:t>
+              <a:t>Независимая</a:t>
             </a:r>
           </a:p>
           <a:p xmlns:a="http://schemas.openxmlformats.org/drawingml/2006/main">
@@ -9126,7 +9126,7 @@
                 <a:ea typeface="Helvetica Neue"/>
                 <a:cs typeface="Helvetica Neue"/>
               </a:rPr>
-              <a:t>verify</a:t>
+              <a:t>проверка</a:t>
             </a:r>
           </a:p>
         </p:txBody>
@@ -9136,7 +9136,7 @@
           <p:cNvPr id="16" name="">
             <a:extLst xmlns:a="http://schemas.openxmlformats.org/drawingml/2006/main">
               <a:ext uri="{FF2B5EF4-FFF2-40B4-BE49-F238E27FC236}">
-                <a16:creationId xmlns:a16="http://schemas.microsoft.com/office/drawing/2014/main" id="{74223E3F-C508-44E2-AED6-2ABAA6952063}"/>
+                <a16:creationId xmlns:a16="http://schemas.microsoft.com/office/drawing/2014/main" id="{1258B601-466C-4900-8DDC-DC024FDD72CD}"/>
               </a:ext>
             </a:extLst>
           </p:cNvPr>
@@ -9284,7 +9284,7 @@
                 <a:ea typeface="Helvetica Neue"/>
                 <a:cs typeface="Helvetica Neue"/>
               </a:rPr>
-              <a:t>Версия и хеш связывают согласие с конкретным предложением.</a:t>
+              <a:t>Учебные блоки не пересекаются с парами. Согласие — на точную версию.</a:t>
             </a:r>
           </a:p>
         </p:txBody>
@@ -9294,7 +9294,7 @@
           <p:cNvPr id="17" name="">
             <a:extLst xmlns:a="http://schemas.openxmlformats.org/drawingml/2006/main">
               <a:ext uri="{FF2B5EF4-FFF2-40B4-BE49-F238E27FC236}">
-                <a16:creationId xmlns:a16="http://schemas.microsoft.com/office/drawing/2014/main" id="{C1E1F540-F3E9-4012-B707-6BEEA5C80F81}"/>
+                <a16:creationId xmlns:a16="http://schemas.microsoft.com/office/drawing/2014/main" id="{4A4C2FB0-56E9-47DD-A9A5-308401C0DD95}"/>
               </a:ext>
             </a:extLst>
           </p:cNvPr>
@@ -9450,7 +9450,7 @@
     </p:spTree>
     <p:extLst>
       <p:ext uri="{BB962C8B-B14F-4D97-AF65-F5344CB8AC3E}">
-        <p14:creationId xmlns:p14="http://schemas.microsoft.com/office/powerpoint/2010/main" val="199038234"/>
+        <p14:creationId xmlns:p14="http://schemas.microsoft.com/office/powerpoint/2010/main" val="170848163"/>
       </p:ext>
     </p:extLst>
   </p:cSld>
@@ -9481,7 +9481,7 @@
           <p:cNvPr id="23" name="">
             <a:extLst xmlns:a="http://schemas.openxmlformats.org/drawingml/2006/main">
               <a:ext uri="{FF2B5EF4-FFF2-40B4-BE49-F238E27FC236}">
-                <a16:creationId xmlns:a16="http://schemas.microsoft.com/office/drawing/2014/main" id="{9FF0427E-5BF5-4E70-BF62-F899F4C31A17}"/>
+                <a16:creationId xmlns:a16="http://schemas.microsoft.com/office/drawing/2014/main" id="{A75FB8D3-337F-4260-AF79-A4C9010178F0}"/>
               </a:ext>
             </a:extLst>
           </p:cNvPr>
@@ -9516,7 +9516,7 @@
           <p:cNvPr id="22" name="">
             <a:extLst xmlns:a="http://schemas.openxmlformats.org/drawingml/2006/main">
               <a:ext uri="{FF2B5EF4-FFF2-40B4-BE49-F238E27FC236}">
-                <a16:creationId xmlns:a16="http://schemas.microsoft.com/office/drawing/2014/main" id="{51EA3E70-1CC1-4BD2-B5A1-7812DF6B9BB4}"/>
+                <a16:creationId xmlns:a16="http://schemas.microsoft.com/office/drawing/2014/main" id="{6B4FBB64-6A4F-4C04-859C-5D2E54489F56}"/>
               </a:ext>
             </a:extLst>
           </p:cNvPr>
@@ -9538,7 +9538,7 @@
             <a:solidFill>
               <a:srgbClr val="4056BD"/>
             </a:solidFill>
-            <a:prstDash val="solid"/>
+            <a:prstDash val="dash"/>
             <a:tailEnd type="triangle" w="med" len="med"/>
           </a:ln>
         </p:spPr>
@@ -9548,7 +9548,7 @@
           <p:cNvPr id="21" name="">
             <a:extLst xmlns:a="http://schemas.openxmlformats.org/drawingml/2006/main">
               <a:ext uri="{FF2B5EF4-FFF2-40B4-BE49-F238E27FC236}">
-                <a16:creationId xmlns:a16="http://schemas.microsoft.com/office/drawing/2014/main" id="{8BF2DAC5-7144-443E-8F94-315FF45165C0}"/>
+                <a16:creationId xmlns:a16="http://schemas.microsoft.com/office/drawing/2014/main" id="{F56B6046-018C-4438-9DF8-28A85B272F2E}"/>
               </a:ext>
             </a:extLst>
           </p:cNvPr>
@@ -9580,7 +9580,7 @@
           <p:cNvPr id="20" name="">
             <a:extLst xmlns:a="http://schemas.openxmlformats.org/drawingml/2006/main">
               <a:ext uri="{FF2B5EF4-FFF2-40B4-BE49-F238E27FC236}">
-                <a16:creationId xmlns:a16="http://schemas.microsoft.com/office/drawing/2014/main" id="{B3063841-DD98-4A11-9813-127A75F1A98C}"/>
+                <a16:creationId xmlns:a16="http://schemas.microsoft.com/office/drawing/2014/main" id="{AEFD6B02-B9DC-40C0-BB1D-3BFE7E24ED7C}"/>
               </a:ext>
             </a:extLst>
           </p:cNvPr>
@@ -9615,7 +9615,7 @@
           <p:cNvPr id="19" name="">
             <a:extLst xmlns:a="http://schemas.openxmlformats.org/drawingml/2006/main">
               <a:ext uri="{FF2B5EF4-FFF2-40B4-BE49-F238E27FC236}">
-                <a16:creationId xmlns:a16="http://schemas.microsoft.com/office/drawing/2014/main" id="{5C816907-58C5-46EC-9172-D93C472D7191}"/>
+                <a16:creationId xmlns:a16="http://schemas.microsoft.com/office/drawing/2014/main" id="{2B9E98C4-5276-4901-8070-A269BC85D1A7}"/>
               </a:ext>
             </a:extLst>
           </p:cNvPr>
@@ -9650,7 +9650,7 @@
           <p:cNvPr id="15" name="">
             <a:extLst xmlns:a="http://schemas.openxmlformats.org/drawingml/2006/main">
               <a:ext uri="{FF2B5EF4-FFF2-40B4-BE49-F238E27FC236}">
-                <a16:creationId xmlns:a16="http://schemas.microsoft.com/office/drawing/2014/main" id="{570A328C-1F2C-41EE-99A8-2C49B884DF33}"/>
+                <a16:creationId xmlns:a16="http://schemas.microsoft.com/office/drawing/2014/main" id="{DFE287F7-714C-4107-BB39-91B8CD3F12FD}"/>
               </a:ext>
             </a:extLst>
           </p:cNvPr>
@@ -9682,7 +9682,7 @@
           <p:cNvPr id="14" name="">
             <a:extLst xmlns:a="http://schemas.openxmlformats.org/drawingml/2006/main">
               <a:ext uri="{FF2B5EF4-FFF2-40B4-BE49-F238E27FC236}">
-                <a16:creationId xmlns:a16="http://schemas.microsoft.com/office/drawing/2014/main" id="{29395350-431E-4887-84D6-05B5A7F6E750}"/>
+                <a16:creationId xmlns:a16="http://schemas.microsoft.com/office/drawing/2014/main" id="{97860304-7FD5-4BFC-BABF-FF3FC0EA071F}"/>
               </a:ext>
             </a:extLst>
           </p:cNvPr>
@@ -9714,7 +9714,7 @@
           <p:cNvPr id="26" name="">
             <a:extLst xmlns:a="http://schemas.openxmlformats.org/drawingml/2006/main">
               <a:ext uri="{FF2B5EF4-FFF2-40B4-BE49-F238E27FC236}">
-                <a16:creationId xmlns:a16="http://schemas.microsoft.com/office/drawing/2014/main" id="{61F46FE8-D28A-43A0-8BFF-B99DFDA30A67}"/>
+                <a16:creationId xmlns:a16="http://schemas.microsoft.com/office/drawing/2014/main" id="{1F756E88-C40F-45A9-99A0-E1E442B8DA05}"/>
               </a:ext>
             </a:extLst>
           </p:cNvPr>
@@ -9872,7 +9872,7 @@
           <p:cNvPr id="2" name="">
             <a:extLst xmlns:a="http://schemas.openxmlformats.org/drawingml/2006/main">
               <a:ext uri="{FF2B5EF4-FFF2-40B4-BE49-F238E27FC236}">
-                <a16:creationId xmlns:a16="http://schemas.microsoft.com/office/drawing/2014/main" id="{763ED299-E2F5-46A1-B6B9-18E2D078CF9A}"/>
+                <a16:creationId xmlns:a16="http://schemas.microsoft.com/office/drawing/2014/main" id="{9C729037-A626-421A-9B84-EFA4690A08A5}"/>
               </a:ext>
             </a:extLst>
           </p:cNvPr>
@@ -10030,7 +10030,7 @@
           <p:cNvPr id="3" name="">
             <a:extLst xmlns:a="http://schemas.openxmlformats.org/drawingml/2006/main">
               <a:ext uri="{FF2B5EF4-FFF2-40B4-BE49-F238E27FC236}">
-                <a16:creationId xmlns:a16="http://schemas.microsoft.com/office/drawing/2014/main" id="{8176EBD8-CF5C-4EF4-B633-8EC8CE674BC7}"/>
+                <a16:creationId xmlns:a16="http://schemas.microsoft.com/office/drawing/2014/main" id="{9C7B08A4-985E-408E-892F-62C58EA7E59B}"/>
               </a:ext>
             </a:extLst>
           </p:cNvPr>
@@ -10178,7 +10178,7 @@
                 <a:ea typeface="Helvetica Neue"/>
                 <a:cs typeface="Helvetica Neue"/>
               </a:rPr>
-              <a:t>Архитектура приложения и recovery</a:t>
+              <a:t>Архитектура CampusPulse</a:t>
             </a:r>
           </a:p>
         </p:txBody>
@@ -10188,7 +10188,7 @@
           <p:cNvPr id="4" name="">
             <a:extLst xmlns:a="http://schemas.openxmlformats.org/drawingml/2006/main">
               <a:ext uri="{FF2B5EF4-FFF2-40B4-BE49-F238E27FC236}">
-                <a16:creationId xmlns:a16="http://schemas.microsoft.com/office/drawing/2014/main" id="{96F5FA53-F4EB-484B-8D80-578AB5A831E5}"/>
+                <a16:creationId xmlns:a16="http://schemas.microsoft.com/office/drawing/2014/main" id="{2687AA56-7496-487E-A8AF-30354C40C024}"/>
               </a:ext>
             </a:extLst>
           </p:cNvPr>
@@ -10218,7 +10218,7 @@
           <p:cNvPr id="5" name="">
             <a:extLst xmlns:a="http://schemas.openxmlformats.org/drawingml/2006/main">
               <a:ext uri="{FF2B5EF4-FFF2-40B4-BE49-F238E27FC236}">
-                <a16:creationId xmlns:a16="http://schemas.microsoft.com/office/drawing/2014/main" id="{E31674FE-4153-4EF9-A0C5-93D20E09CE30}"/>
+                <a16:creationId xmlns:a16="http://schemas.microsoft.com/office/drawing/2014/main" id="{AA6AFF6A-AB14-418F-A561-2FB7FC5D367D}"/>
               </a:ext>
             </a:extLst>
           </p:cNvPr>
@@ -10376,7 +10376,7 @@
           <p:cNvPr id="6" name="">
             <a:extLst xmlns:a="http://schemas.openxmlformats.org/drawingml/2006/main">
               <a:ext uri="{FF2B5EF4-FFF2-40B4-BE49-F238E27FC236}">
-                <a16:creationId xmlns:a16="http://schemas.microsoft.com/office/drawing/2014/main" id="{F1A8CE6A-64F1-4D57-88E9-642CC8D70361}"/>
+                <a16:creationId xmlns:a16="http://schemas.microsoft.com/office/drawing/2014/main" id="{0C4BD78E-6C39-4FC7-A538-973D6CE6DBB2}"/>
               </a:ext>
             </a:extLst>
           </p:cNvPr>
@@ -10561,7 +10561,7 @@
           <p:cNvPr id="7" name="">
             <a:extLst xmlns:a="http://schemas.openxmlformats.org/drawingml/2006/main">
               <a:ext uri="{FF2B5EF4-FFF2-40B4-BE49-F238E27FC236}">
-                <a16:creationId xmlns:a16="http://schemas.microsoft.com/office/drawing/2014/main" id="{DDF1872A-0960-47B3-A6CC-410DC89E9C32}"/>
+                <a16:creationId xmlns:a16="http://schemas.microsoft.com/office/drawing/2014/main" id="{32493377-CD1F-4C2F-9A3B-CAF61E2935DA}"/>
               </a:ext>
             </a:extLst>
           </p:cNvPr>
@@ -10746,7 +10746,7 @@
           <p:cNvPr id="8" name="">
             <a:extLst xmlns:a="http://schemas.openxmlformats.org/drawingml/2006/main">
               <a:ext uri="{FF2B5EF4-FFF2-40B4-BE49-F238E27FC236}">
-                <a16:creationId xmlns:a16="http://schemas.microsoft.com/office/drawing/2014/main" id="{D15F937F-6632-4FF1-A324-414D74B4653C}"/>
+                <a16:creationId xmlns:a16="http://schemas.microsoft.com/office/drawing/2014/main" id="{C2969E5E-1F85-435A-97B4-A4B001562F1D}"/>
               </a:ext>
             </a:extLst>
           </p:cNvPr>
@@ -10931,7 +10931,7 @@
           <p:cNvPr id="9" name="">
             <a:extLst xmlns:a="http://schemas.openxmlformats.org/drawingml/2006/main">
               <a:ext uri="{FF2B5EF4-FFF2-40B4-BE49-F238E27FC236}">
-                <a16:creationId xmlns:a16="http://schemas.microsoft.com/office/drawing/2014/main" id="{69BDAE20-C40B-442A-9365-32374C6FB863}"/>
+                <a16:creationId xmlns:a16="http://schemas.microsoft.com/office/drawing/2014/main" id="{DF4173AC-1C61-4816-908A-9719E465F833}"/>
               </a:ext>
             </a:extLst>
           </p:cNvPr>
@@ -11093,7 +11093,7 @@
           <p:cNvPr id="10" name="">
             <a:extLst xmlns:a="http://schemas.openxmlformats.org/drawingml/2006/main">
               <a:ext uri="{FF2B5EF4-FFF2-40B4-BE49-F238E27FC236}">
-                <a16:creationId xmlns:a16="http://schemas.microsoft.com/office/drawing/2014/main" id="{159D2A93-6D7D-422D-A7C5-2B338663BFDA}"/>
+                <a16:creationId xmlns:a16="http://schemas.microsoft.com/office/drawing/2014/main" id="{92398382-2F93-4F36-8263-9966CE7751F7}"/>
               </a:ext>
             </a:extLst>
           </p:cNvPr>
@@ -11278,7 +11278,7 @@
           <p:cNvPr id="11" name="">
             <a:extLst xmlns:a="http://schemas.openxmlformats.org/drawingml/2006/main">
               <a:ext uri="{FF2B5EF4-FFF2-40B4-BE49-F238E27FC236}">
-                <a16:creationId xmlns:a16="http://schemas.microsoft.com/office/drawing/2014/main" id="{F463CE0D-960A-4131-A3F2-F1119E28F537}"/>
+                <a16:creationId xmlns:a16="http://schemas.microsoft.com/office/drawing/2014/main" id="{58105A65-D86A-4DAE-A45E-784477819223}"/>
               </a:ext>
             </a:extLst>
           </p:cNvPr>
@@ -11463,7 +11463,7 @@
           <p:cNvPr id="12" name="">
             <a:extLst xmlns:a="http://schemas.openxmlformats.org/drawingml/2006/main">
               <a:ext uri="{FF2B5EF4-FFF2-40B4-BE49-F238E27FC236}">
-                <a16:creationId xmlns:a16="http://schemas.microsoft.com/office/drawing/2014/main" id="{D1DC00C0-A14B-4DC4-B382-37C73BB45D70}"/>
+                <a16:creationId xmlns:a16="http://schemas.microsoft.com/office/drawing/2014/main" id="{096F6E73-1938-43B5-A099-CF46F4A7E861}"/>
               </a:ext>
             </a:extLst>
           </p:cNvPr>
@@ -11625,7 +11625,7 @@
           <p:cNvPr id="13" name="">
             <a:extLst xmlns:a="http://schemas.openxmlformats.org/drawingml/2006/main">
               <a:ext uri="{FF2B5EF4-FFF2-40B4-BE49-F238E27FC236}">
-                <a16:creationId xmlns:a16="http://schemas.microsoft.com/office/drawing/2014/main" id="{7637949E-6C20-45B5-898E-7A3F966ACC3F}"/>
+                <a16:creationId xmlns:a16="http://schemas.microsoft.com/office/drawing/2014/main" id="{C73D4777-F6E2-49C7-8AFF-9E50807B3F43}"/>
               </a:ext>
             </a:extLst>
           </p:cNvPr>
@@ -11810,7 +11810,7 @@
           <p:cNvPr id="16" name="">
             <a:extLst xmlns:a="http://schemas.openxmlformats.org/drawingml/2006/main">
               <a:ext uri="{FF2B5EF4-FFF2-40B4-BE49-F238E27FC236}">
-                <a16:creationId xmlns:a16="http://schemas.microsoft.com/office/drawing/2014/main" id="{97391E0B-F94C-41BB-B28E-FDAB560A703B}"/>
+                <a16:creationId xmlns:a16="http://schemas.microsoft.com/office/drawing/2014/main" id="{27D9F79B-D52C-458D-9499-AFA5AE5B0F4D}"/>
               </a:ext>
             </a:extLst>
           </p:cNvPr>
@@ -11839,7 +11839,7 @@
           <p:cNvPr id="17" name="">
             <a:extLst xmlns:a="http://schemas.openxmlformats.org/drawingml/2006/main">
               <a:ext uri="{FF2B5EF4-FFF2-40B4-BE49-F238E27FC236}">
-                <a16:creationId xmlns:a16="http://schemas.microsoft.com/office/drawing/2014/main" id="{F2DECEE5-E822-4764-ABAD-59A54C923F08}"/>
+                <a16:creationId xmlns:a16="http://schemas.microsoft.com/office/drawing/2014/main" id="{6F94C2AE-4912-492D-A307-25FA48BF746F}"/>
               </a:ext>
             </a:extLst>
           </p:cNvPr>
@@ -11868,7 +11868,7 @@
           <p:cNvPr id="18" name="">
             <a:extLst xmlns:a="http://schemas.openxmlformats.org/drawingml/2006/main">
               <a:ext uri="{FF2B5EF4-FFF2-40B4-BE49-F238E27FC236}">
-                <a16:creationId xmlns:a16="http://schemas.microsoft.com/office/drawing/2014/main" id="{110A9CB3-F41F-4C5D-9198-229A1D9EA46F}"/>
+                <a16:creationId xmlns:a16="http://schemas.microsoft.com/office/drawing/2014/main" id="{1B1094CB-05D1-495B-8CE9-8025DA42A6BD}"/>
               </a:ext>
             </a:extLst>
           </p:cNvPr>
@@ -11896,7 +11896,7 @@
           <p:cNvPr id="24" name="">
             <a:extLst xmlns:a="http://schemas.openxmlformats.org/drawingml/2006/main">
               <a:ext uri="{FF2B5EF4-FFF2-40B4-BE49-F238E27FC236}">
-                <a16:creationId xmlns:a16="http://schemas.microsoft.com/office/drawing/2014/main" id="{76C76D0C-2699-4B21-948A-9AA879894D2D}"/>
+                <a16:creationId xmlns:a16="http://schemas.microsoft.com/office/drawing/2014/main" id="{F5F9F6FC-D811-4A8C-A40D-E97EF383CB0A}"/>
               </a:ext>
             </a:extLst>
           </p:cNvPr>
@@ -12044,7 +12044,7 @@
                 <a:ea typeface="Helvetica Neue"/>
                 <a:cs typeface="Helvetica Neue"/>
               </a:rPr>
-              <a:t>Обычный чат</a:t>
+              <a:t>Чат и распознавание файлов</a:t>
             </a:r>
           </a:p>
         </p:txBody>
@@ -12054,7 +12054,7 @@
           <p:cNvPr id="25" name="">
             <a:extLst xmlns:a="http://schemas.openxmlformats.org/drawingml/2006/main">
               <a:ext uri="{FF2B5EF4-FFF2-40B4-BE49-F238E27FC236}">
-                <a16:creationId xmlns:a16="http://schemas.microsoft.com/office/drawing/2014/main" id="{77ADFB8C-E9EB-4F8A-8351-42849FD43985}"/>
+                <a16:creationId xmlns:a16="http://schemas.microsoft.com/office/drawing/2014/main" id="{3447B202-53F5-4249-A95B-8A16107AFBB0}"/>
               </a:ext>
             </a:extLst>
           </p:cNvPr>
@@ -12202,7 +12202,7 @@
                 <a:ea typeface="Helvetica Neue"/>
                 <a:cs typeface="Helvetica Neue"/>
               </a:rPr>
-              <a:t>Пунктир: персональный cloud recovery не подтверждён</a:t>
+              <a:t>Путь через Engine: новый study-agent читает; recovery пишет после согласия</a:t>
             </a:r>
           </a:p>
         </p:txBody>
@@ -12210,7 +12210,7 @@
     </p:spTree>
     <p:extLst>
       <p:ext uri="{BB962C8B-B14F-4D97-AF65-F5344CB8AC3E}">
-        <p14:creationId xmlns:p14="http://schemas.microsoft.com/office/powerpoint/2010/main" val="1207983255"/>
+        <p14:creationId xmlns:p14="http://schemas.microsoft.com/office/powerpoint/2010/main" val="1488378577"/>
       </p:ext>
     </p:extLst>
   </p:cSld>
@@ -12241,7 +12241,7 @@
           <p:cNvPr id="9" name="">
             <a:extLst xmlns:a="http://schemas.openxmlformats.org/drawingml/2006/main">
               <a:ext uri="{FF2B5EF4-FFF2-40B4-BE49-F238E27FC236}">
-                <a16:creationId xmlns:a16="http://schemas.microsoft.com/office/drawing/2014/main" id="{D32DD48D-F0FD-42B4-AF9D-031E4A90CCFF}"/>
+                <a16:creationId xmlns:a16="http://schemas.microsoft.com/office/drawing/2014/main" id="{C3539122-B819-4114-8709-134B3342006C}"/>
               </a:ext>
             </a:extLst>
           </p:cNvPr>
@@ -12399,7 +12399,7 @@
           <p:cNvPr id="2" name="">
             <a:extLst xmlns:a="http://schemas.openxmlformats.org/drawingml/2006/main">
               <a:ext uri="{FF2B5EF4-FFF2-40B4-BE49-F238E27FC236}">
-                <a16:creationId xmlns:a16="http://schemas.microsoft.com/office/drawing/2014/main" id="{F19B5441-69A4-47C5-99D5-1D6DD3165E48}"/>
+                <a16:creationId xmlns:a16="http://schemas.microsoft.com/office/drawing/2014/main" id="{C942203B-297C-4511-AE74-5E4EE8A2E95C}"/>
               </a:ext>
             </a:extLst>
           </p:cNvPr>
@@ -12557,7 +12557,7 @@
           <p:cNvPr id="3" name="">
             <a:extLst xmlns:a="http://schemas.openxmlformats.org/drawingml/2006/main">
               <a:ext uri="{FF2B5EF4-FFF2-40B4-BE49-F238E27FC236}">
-                <a16:creationId xmlns:a16="http://schemas.microsoft.com/office/drawing/2014/main" id="{ED462DA2-7442-4588-8114-4EFCF8EE0581}"/>
+                <a16:creationId xmlns:a16="http://schemas.microsoft.com/office/drawing/2014/main" id="{77DF243B-7C43-451E-B190-ED8579129ABA}"/>
               </a:ext>
             </a:extLst>
           </p:cNvPr>
@@ -12715,7 +12715,7 @@
           <p:cNvPr id="4" name="">
             <a:extLst xmlns:a="http://schemas.openxmlformats.org/drawingml/2006/main">
               <a:ext uri="{FF2B5EF4-FFF2-40B4-BE49-F238E27FC236}">
-                <a16:creationId xmlns:a16="http://schemas.microsoft.com/office/drawing/2014/main" id="{6FC79248-5EE1-4233-B2AA-D22F166A7C72}"/>
+                <a16:creationId xmlns:a16="http://schemas.microsoft.com/office/drawing/2014/main" id="{1E3EFEBC-3B7A-4E37-960D-206E29BF74F3}"/>
               </a:ext>
             </a:extLst>
           </p:cNvPr>
@@ -12873,7 +12873,7 @@
           <p:cNvPr id="5" name="">
             <a:extLst xmlns:a="http://schemas.openxmlformats.org/drawingml/2006/main">
               <a:ext uri="{FF2B5EF4-FFF2-40B4-BE49-F238E27FC236}">
-                <a16:creationId xmlns:a16="http://schemas.microsoft.com/office/drawing/2014/main" id="{664D9E44-8E21-4573-ACFD-CB57B75E4ECC}"/>
+                <a16:creationId xmlns:a16="http://schemas.microsoft.com/office/drawing/2014/main" id="{FB6156F8-97D8-4E43-9455-EAE2A83A318C}"/>
               </a:ext>
             </a:extLst>
           </p:cNvPr>
@@ -12903,7 +12903,7 @@
           <p:cNvPr id="6" name="">
             <a:extLst xmlns:a="http://schemas.openxmlformats.org/drawingml/2006/main">
               <a:ext uri="{FF2B5EF4-FFF2-40B4-BE49-F238E27FC236}">
-                <a16:creationId xmlns:a16="http://schemas.microsoft.com/office/drawing/2014/main" id="{BE7BCB81-BDB5-44CD-B287-5EE1E6DA0A6B}"/>
+                <a16:creationId xmlns:a16="http://schemas.microsoft.com/office/drawing/2014/main" id="{B897A354-B995-4ADC-9083-546391719E4D}"/>
               </a:ext>
             </a:extLst>
           </p:cNvPr>
@@ -13061,7 +13061,7 @@
           <p:cNvPr id="7" name="">
             <a:extLst xmlns:a="http://schemas.openxmlformats.org/drawingml/2006/main">
               <a:ext uri="{FF2B5EF4-FFF2-40B4-BE49-F238E27FC236}">
-                <a16:creationId xmlns:a16="http://schemas.microsoft.com/office/drawing/2014/main" id="{85A2F96F-CDC2-49A6-B23C-8B9743BD1CC5}"/>
+                <a16:creationId xmlns:a16="http://schemas.microsoft.com/office/drawing/2014/main" id="{850A8320-21B3-4B5C-B15B-056ACF467114}"/>
               </a:ext>
             </a:extLst>
           </p:cNvPr>
@@ -13147,7 +13147,7 @@
                           <a:ea typeface="Helvetica Neue"/>
                           <a:cs typeface="Helvetica Neue"/>
                         </a:rPr>
-                        <a:t>Роль в recovery</a:t>
+                        <a:t>Роль в сценарии</a:t>
                       </a:r>
                     </a:p>
                   </a:txBody>
@@ -13193,7 +13193,7 @@
                           <a:ea typeface="Helvetica Neue"/>
                           <a:cs typeface="Helvetica Neue"/>
                         </a:rPr>
-                        <a:t>MCP  read_assignments</a:t>
+                        <a:t>MCP  read_assignments / read_schedule</a:t>
                       </a:r>
                     </a:p>
                   </a:txBody>
@@ -13237,7 +13237,7 @@
                           <a:ea typeface="Helvetica Neue"/>
                           <a:cs typeface="Helvetica Neue"/>
                         </a:rPr>
-                        <a:t>Прочитать задания и сохранить снимок</a:t>
+                        <a:t>Study-agent: задания и пары (только чтение)</a:t>
                       </a:r>
                     </a:p>
                   </a:txBody>
@@ -13605,7 +13605,7 @@
           <p:cNvPr id="8" name="">
             <a:extLst xmlns:a="http://schemas.openxmlformats.org/drawingml/2006/main">
               <a:ext uri="{FF2B5EF4-FFF2-40B4-BE49-F238E27FC236}">
-                <a16:creationId xmlns:a16="http://schemas.microsoft.com/office/drawing/2014/main" id="{DAA11CCC-5CAC-4B3A-8034-FC0C320E47F9}"/>
+                <a16:creationId xmlns:a16="http://schemas.microsoft.com/office/drawing/2014/main" id="{1AFB0FB5-695F-4C1F-A4AA-0240AA7DE240}"/>
               </a:ext>
             </a:extLst>
           </p:cNvPr>
@@ -13753,7 +13753,7 @@
                 <a:ea typeface="Helvetica Neue"/>
                 <a:cs typeface="Helvetica Neue"/>
               </a:rPr>
-              <a:t>Изменение источников отменяет старое согласие. Неясный результат записи не вызывает автоматический повтор.</a:t>
+              <a:t>Recovery-инструменты apply/verify отделены от study-agent. Неясный результат записи не считается успехом.</a:t>
             </a:r>
           </a:p>
         </p:txBody>
@@ -13761,7 +13761,7 @@
     </p:spTree>
     <p:extLst>
       <p:ext uri="{BB962C8B-B14F-4D97-AF65-F5344CB8AC3E}">
-        <p14:creationId xmlns:p14="http://schemas.microsoft.com/office/powerpoint/2010/main" val="1554136126"/>
+        <p14:creationId xmlns:p14="http://schemas.microsoft.com/office/powerpoint/2010/main" val="1985223496"/>
       </p:ext>
     </p:extLst>
   </p:cSld>
@@ -13792,7 +13792,7 @@
           <p:cNvPr id="12" name="">
             <a:extLst xmlns:a="http://schemas.openxmlformats.org/drawingml/2006/main">
               <a:ext uri="{FF2B5EF4-FFF2-40B4-BE49-F238E27FC236}">
-                <a16:creationId xmlns:a16="http://schemas.microsoft.com/office/drawing/2014/main" id="{1F3803D7-0BE8-4553-B412-9DFEDBF95E87}"/>
+                <a16:creationId xmlns:a16="http://schemas.microsoft.com/office/drawing/2014/main" id="{513D7727-7B91-4BDE-AEA7-643609BE3846}"/>
               </a:ext>
             </a:extLst>
           </p:cNvPr>
@@ -13950,7 +13950,7 @@
           <p:cNvPr id="2" name="">
             <a:extLst xmlns:a="http://schemas.openxmlformats.org/drawingml/2006/main">
               <a:ext uri="{FF2B5EF4-FFF2-40B4-BE49-F238E27FC236}">
-                <a16:creationId xmlns:a16="http://schemas.microsoft.com/office/drawing/2014/main" id="{11A3C77F-DCEE-4317-9233-6B0EFB1BE203}"/>
+                <a16:creationId xmlns:a16="http://schemas.microsoft.com/office/drawing/2014/main" id="{8ADD44E2-E9D9-4F3B-B45D-3041DD1AF6C5}"/>
               </a:ext>
             </a:extLst>
           </p:cNvPr>
@@ -14108,7 +14108,7 @@
           <p:cNvPr id="3" name="">
             <a:extLst xmlns:a="http://schemas.openxmlformats.org/drawingml/2006/main">
               <a:ext uri="{FF2B5EF4-FFF2-40B4-BE49-F238E27FC236}">
-                <a16:creationId xmlns:a16="http://schemas.microsoft.com/office/drawing/2014/main" id="{26AC1B0F-A4B9-45DE-BE5D-60C71E175E5A}"/>
+                <a16:creationId xmlns:a16="http://schemas.microsoft.com/office/drawing/2014/main" id="{EF5A29F3-0DD2-4AED-96AE-8479DE6430F6}"/>
               </a:ext>
             </a:extLst>
           </p:cNvPr>
@@ -14266,7 +14266,7 @@
           <p:cNvPr id="4" name="">
             <a:extLst xmlns:a="http://schemas.openxmlformats.org/drawingml/2006/main">
               <a:ext uri="{FF2B5EF4-FFF2-40B4-BE49-F238E27FC236}">
-                <a16:creationId xmlns:a16="http://schemas.microsoft.com/office/drawing/2014/main" id="{AB5A9266-3B91-4F48-AB49-C31D5FC69CA9}"/>
+                <a16:creationId xmlns:a16="http://schemas.microsoft.com/office/drawing/2014/main" id="{D4A6EB2E-57D7-4E54-BA18-7277531D4343}"/>
               </a:ext>
             </a:extLst>
           </p:cNvPr>
@@ -14414,7 +14414,7 @@
                 <a:ea typeface="Helvetica Neue"/>
                 <a:cs typeface="Helvetica Neue"/>
               </a:rPr>
-              <a:t>Облачный статус по checkpoint от 20 октября 2026</a:t>
+              <a:t>Handoff Мерея от 22 октября: ветка codex/pitch-agent-cloud</a:t>
             </a:r>
           </a:p>
         </p:txBody>
@@ -14424,7 +14424,7 @@
           <p:cNvPr id="5" name="">
             <a:extLst xmlns:a="http://schemas.openxmlformats.org/drawingml/2006/main">
               <a:ext uri="{FF2B5EF4-FFF2-40B4-BE49-F238E27FC236}">
-                <a16:creationId xmlns:a16="http://schemas.microsoft.com/office/drawing/2014/main" id="{57C4A2DA-AA89-4BDB-B1C9-DC249CD07D80}"/>
+                <a16:creationId xmlns:a16="http://schemas.microsoft.com/office/drawing/2014/main" id="{ACC45EFB-657F-46A0-93CD-45EB4EBF6E4B}"/>
               </a:ext>
             </a:extLst>
           </p:cNvPr>
@@ -14454,7 +14454,7 @@
           <p:cNvPr id="6" name="">
             <a:extLst xmlns:a="http://schemas.openxmlformats.org/drawingml/2006/main">
               <a:ext uri="{FF2B5EF4-FFF2-40B4-BE49-F238E27FC236}">
-                <a16:creationId xmlns:a16="http://schemas.microsoft.com/office/drawing/2014/main" id="{AABA2D3D-9273-4A2D-9710-811AD058BB5F}"/>
+                <a16:creationId xmlns:a16="http://schemas.microsoft.com/office/drawing/2014/main" id="{F1CDD6E6-A25A-40AE-A64C-0EE81F303D70}"/>
               </a:ext>
             </a:extLst>
           </p:cNvPr>
@@ -14612,7 +14612,7 @@
           <p:cNvPr id="7" name="">
             <a:extLst xmlns:a="http://schemas.openxmlformats.org/drawingml/2006/main">
               <a:ext uri="{FF2B5EF4-FFF2-40B4-BE49-F238E27FC236}">
-                <a16:creationId xmlns:a16="http://schemas.microsoft.com/office/drawing/2014/main" id="{AD65B9A8-3C94-4F50-8B36-509657D20098}"/>
+                <a16:creationId xmlns:a16="http://schemas.microsoft.com/office/drawing/2014/main" id="{93EFB5BE-A36A-4E0B-8406-71801BF55D15}"/>
               </a:ext>
             </a:extLst>
           </p:cNvPr>
@@ -14760,7 +14760,7 @@
                 <a:ea typeface="Helvetica Neue"/>
                 <a:cs typeface="Helvetica Neue"/>
               </a:rPr>
-              <a:t>Зафиксировано в отчёте</a:t>
+              <a:t>Реализовано в новой ветке</a:t>
             </a:r>
           </a:p>
         </p:txBody>
@@ -14770,7 +14770,7 @@
           <p:cNvPr id="8" name="">
             <a:extLst xmlns:a="http://schemas.openxmlformats.org/drawingml/2006/main">
               <a:ext uri="{FF2B5EF4-FFF2-40B4-BE49-F238E27FC236}">
-                <a16:creationId xmlns:a16="http://schemas.microsoft.com/office/drawing/2014/main" id="{B8151643-9A80-4256-BCC9-FC9F40DE4AF7}"/>
+                <a16:creationId xmlns:a16="http://schemas.microsoft.com/office/drawing/2014/main" id="{C2C9EEB5-050B-494D-AFBA-596E095A9C62}"/>
               </a:ext>
             </a:extLst>
           </p:cNvPr>
@@ -14918,7 +14918,7 @@
                 <a:ea typeface="Helvetica Neue"/>
                 <a:cs typeface="Helvetica Neue"/>
               </a:rPr>
-              <a:t>Cloud Run, Agent Engine и MCP</a:t>
+              <a:t>Чат → Agent Engine → приватный MCP</a:t>
             </a:r>
           </a:p>
           <a:p xmlns:a="http://schemas.openxmlformats.org/drawingml/2006/main">
@@ -14941,7 +14941,7 @@
                 <a:ea typeface="Helvetica Neue"/>
                 <a:cs typeface="Helvetica Neue"/>
               </a:rPr>
-              <a:t>Приватная операция async_query</a:t>
+              <a:t>read_assignments и read_schedule</a:t>
             </a:r>
           </a:p>
           <a:p xmlns:a="http://schemas.openxmlformats.org/drawingml/2006/main">
@@ -14964,7 +14964,7 @@
                 <a:ea typeface="Helvetica Neue"/>
                 <a:cs typeface="Helvetica Neue"/>
               </a:rPr>
-              <a:t>Проверки инфраструктуры и авторизации</a:t>
+              <a:t>Фактический trace инструментов</a:t>
             </a:r>
           </a:p>
         </p:txBody>
@@ -14974,7 +14974,7 @@
           <p:cNvPr id="9" name="">
             <a:extLst xmlns:a="http://schemas.openxmlformats.org/drawingml/2006/main">
               <a:ext uri="{FF2B5EF4-FFF2-40B4-BE49-F238E27FC236}">
-                <a16:creationId xmlns:a16="http://schemas.microsoft.com/office/drawing/2014/main" id="{935044BC-F6C2-4AA1-BAFB-26202F5C5BCB}"/>
+                <a16:creationId xmlns:a16="http://schemas.microsoft.com/office/drawing/2014/main" id="{1C0574F9-0123-40D4-A376-0952B54C72E7}"/>
               </a:ext>
             </a:extLst>
           </p:cNvPr>
@@ -15122,7 +15122,7 @@
                 <a:ea typeface="Helvetica Neue"/>
                 <a:cs typeface="Helvetica Neue"/>
               </a:rPr>
-              <a:t>До персонального recovery</a:t>
+              <a:t>Что ещё не подтверждено</a:t>
             </a:r>
           </a:p>
         </p:txBody>
@@ -15132,7 +15132,7 @@
           <p:cNvPr id="10" name="">
             <a:extLst xmlns:a="http://schemas.openxmlformats.org/drawingml/2006/main">
               <a:ext uri="{FF2B5EF4-FFF2-40B4-BE49-F238E27FC236}">
-                <a16:creationId xmlns:a16="http://schemas.microsoft.com/office/drawing/2014/main" id="{18508734-DD40-44AB-9513-7D7FAFD22DC5}"/>
+                <a16:creationId xmlns:a16="http://schemas.microsoft.com/office/drawing/2014/main" id="{E36E6060-5053-46E5-B4E4-08A9FA5A99E1}"/>
               </a:ext>
             </a:extLst>
           </p:cNvPr>
@@ -15280,7 +15280,7 @@
                 <a:ea typeface="Helvetica Neue"/>
                 <a:cs typeface="Helvetica Neue"/>
               </a:rPr>
-              <a:t>Общие версии кода и настроек</a:t>
+              <a:t>Приёмка опубликованного сайта</a:t>
             </a:r>
           </a:p>
           <a:p xmlns:a="http://schemas.openxmlformats.org/drawingml/2006/main">
@@ -15303,7 +15303,7 @@
                 <a:ea typeface="Helvetica Neue"/>
                 <a:cs typeface="Helvetica Neue"/>
               </a:rPr>
-              <a:t>Реальные привязки двух пользователей</a:t>
+              <a:t>Распознавание реальных PDF / фото</a:t>
             </a:r>
           </a:p>
           <a:p xmlns:a="http://schemas.openxmlformats.org/drawingml/2006/main">
@@ -15326,7 +15326,7 @@
                 <a:ea typeface="Helvetica Neue"/>
                 <a:cs typeface="Helvetica Neue"/>
               </a:rPr>
-              <a:t>Отдельные разрешённые Calendars</a:t>
+              <a:t>Интеграция нашей UI-ветки</a:t>
             </a:r>
           </a:p>
           <a:p xmlns:a="http://schemas.openxmlformats.org/drawingml/2006/main">
@@ -15349,7 +15349,7 @@
                 <a:ea typeface="Helvetica Neue"/>
                 <a:cs typeface="Helvetica Neue"/>
               </a:rPr>
-              <a:t>Полный live-цикл apply и verify</a:t>
+              <a:t>Запись Calendar и live verify</a:t>
             </a:r>
           </a:p>
         </p:txBody>
@@ -15359,7 +15359,7 @@
           <p:cNvPr id="11" name="">
             <a:extLst xmlns:a="http://schemas.openxmlformats.org/drawingml/2006/main">
               <a:ext uri="{FF2B5EF4-FFF2-40B4-BE49-F238E27FC236}">
-                <a16:creationId xmlns:a16="http://schemas.microsoft.com/office/drawing/2014/main" id="{79AFD25F-D97A-4A3D-BCBB-C456F9F50EB2}"/>
+                <a16:creationId xmlns:a16="http://schemas.microsoft.com/office/drawing/2014/main" id="{E85F60F9-3DFB-4EFC-8B0E-B992BA1C5A91}"/>
               </a:ext>
             </a:extLst>
           </p:cNvPr>
@@ -15507,7 +15507,7 @@
                 <a:ea typeface="Helvetica Neue"/>
                 <a:cs typeface="Helvetica Neue"/>
               </a:rPr>
-              <a:t>Доступность ресурсов и пользовательский сценарий проверяются отдельно.</a:t>
+              <a:t>Этот read-only релиз не включает recovery и запись в Calendar.</a:t>
             </a:r>
           </a:p>
         </p:txBody>
@@ -15515,7 +15515,7 @@
     </p:spTree>
     <p:extLst>
       <p:ext uri="{BB962C8B-B14F-4D97-AF65-F5344CB8AC3E}">
-        <p14:creationId xmlns:p14="http://schemas.microsoft.com/office/powerpoint/2010/main" val="1663687918"/>
+        <p14:creationId xmlns:p14="http://schemas.microsoft.com/office/powerpoint/2010/main" val="788692995"/>
       </p:ext>
     </p:extLst>
   </p:cSld>
@@ -15546,7 +15546,7 @@
           <p:cNvPr id="15" name="">
             <a:extLst xmlns:a="http://schemas.openxmlformats.org/drawingml/2006/main">
               <a:ext uri="{FF2B5EF4-FFF2-40B4-BE49-F238E27FC236}">
-                <a16:creationId xmlns:a16="http://schemas.microsoft.com/office/drawing/2014/main" id="{EFAACEC6-2815-4270-A102-BC0ACE8002D8}"/>
+                <a16:creationId xmlns:a16="http://schemas.microsoft.com/office/drawing/2014/main" id="{229D4D56-F52A-49B1-8478-A4B039DE2378}"/>
               </a:ext>
             </a:extLst>
           </p:cNvPr>
@@ -15704,7 +15704,7 @@
           <p:cNvPr id="2" name="">
             <a:extLst xmlns:a="http://schemas.openxmlformats.org/drawingml/2006/main">
               <a:ext uri="{FF2B5EF4-FFF2-40B4-BE49-F238E27FC236}">
-                <a16:creationId xmlns:a16="http://schemas.microsoft.com/office/drawing/2014/main" id="{D5CBBDD2-9118-42D2-88B5-CFE3CD6A1D2F}"/>
+                <a16:creationId xmlns:a16="http://schemas.microsoft.com/office/drawing/2014/main" id="{9B3EE408-0666-4D9C-AFF5-DBAEDFFF32ED}"/>
               </a:ext>
             </a:extLst>
           </p:cNvPr>
@@ -15862,7 +15862,7 @@
           <p:cNvPr id="3" name="">
             <a:extLst xmlns:a="http://schemas.openxmlformats.org/drawingml/2006/main">
               <a:ext uri="{FF2B5EF4-FFF2-40B4-BE49-F238E27FC236}">
-                <a16:creationId xmlns:a16="http://schemas.microsoft.com/office/drawing/2014/main" id="{CC2C863E-DF5D-4B54-8BDA-884D4B20E937}"/>
+                <a16:creationId xmlns:a16="http://schemas.microsoft.com/office/drawing/2014/main" id="{5F93350A-C458-48C5-A3A2-0428442CA347}"/>
               </a:ext>
             </a:extLst>
           </p:cNvPr>
@@ -16020,7 +16020,7 @@
           <p:cNvPr id="4" name="">
             <a:extLst xmlns:a="http://schemas.openxmlformats.org/drawingml/2006/main">
               <a:ext uri="{FF2B5EF4-FFF2-40B4-BE49-F238E27FC236}">
-                <a16:creationId xmlns:a16="http://schemas.microsoft.com/office/drawing/2014/main" id="{B1941E3F-694E-402D-A79A-02E80787D9A7}"/>
+                <a16:creationId xmlns:a16="http://schemas.microsoft.com/office/drawing/2014/main" id="{CFFC8C17-7E05-421C-98C6-B2B3CD2D4CA6}"/>
               </a:ext>
             </a:extLst>
           </p:cNvPr>
@@ -16168,7 +16168,7 @@
                 <a:ea typeface="Helvetica Neue"/>
                 <a:cs typeface="Helvetica Neue"/>
               </a:rPr>
-              <a:t>Свежий локальный прогон 21 октября 2026, изолированное окружение</a:t>
+              <a:t>22 октября 2026: тестовые внешние сервисы, Firestore Emulator</a:t>
             </a:r>
           </a:p>
         </p:txBody>
@@ -16178,7 +16178,7 @@
           <p:cNvPr id="5" name="">
             <a:extLst xmlns:a="http://schemas.openxmlformats.org/drawingml/2006/main">
               <a:ext uri="{FF2B5EF4-FFF2-40B4-BE49-F238E27FC236}">
-                <a16:creationId xmlns:a16="http://schemas.microsoft.com/office/drawing/2014/main" id="{F026F5AE-4415-49A8-B753-6D9470E7C541}"/>
+                <a16:creationId xmlns:a16="http://schemas.microsoft.com/office/drawing/2014/main" id="{1145ACA8-5AD4-4E00-A374-A5786ED9DF3B}"/>
               </a:ext>
             </a:extLst>
           </p:cNvPr>
@@ -16208,7 +16208,7 @@
           <p:cNvPr id="6" name="">
             <a:extLst xmlns:a="http://schemas.openxmlformats.org/drawingml/2006/main">
               <a:ext uri="{FF2B5EF4-FFF2-40B4-BE49-F238E27FC236}">
-                <a16:creationId xmlns:a16="http://schemas.microsoft.com/office/drawing/2014/main" id="{89545FC8-586C-4BAD-A8EF-DD8DB6517CDF}"/>
+                <a16:creationId xmlns:a16="http://schemas.microsoft.com/office/drawing/2014/main" id="{86A5D847-DB42-48EA-AC55-041E8622F642}"/>
               </a:ext>
             </a:extLst>
           </p:cNvPr>
@@ -16366,7 +16366,7 @@
           <p:cNvPr id="7" name="">
             <a:extLst xmlns:a="http://schemas.openxmlformats.org/drawingml/2006/main">
               <a:ext uri="{FF2B5EF4-FFF2-40B4-BE49-F238E27FC236}">
-                <a16:creationId xmlns:a16="http://schemas.microsoft.com/office/drawing/2014/main" id="{9110A86A-91A8-413F-A2D7-4BCC3D4F40BA}"/>
+                <a16:creationId xmlns:a16="http://schemas.microsoft.com/office/drawing/2014/main" id="{69190744-6CDD-4595-85E8-395923370562}"/>
               </a:ext>
             </a:extLst>
           </p:cNvPr>
@@ -16514,7 +16514,7 @@
                 <a:ea typeface="Helvetica Neue"/>
                 <a:cs typeface="Helvetica Neue"/>
               </a:rPr>
-              <a:t>2256</a:t>
+              <a:t>2369</a:t>
             </a:r>
           </a:p>
         </p:txBody>
@@ -16524,7 +16524,7 @@
           <p:cNvPr id="8" name="">
             <a:extLst xmlns:a="http://schemas.openxmlformats.org/drawingml/2006/main">
               <a:ext uri="{FF2B5EF4-FFF2-40B4-BE49-F238E27FC236}">
-                <a16:creationId xmlns:a16="http://schemas.microsoft.com/office/drawing/2014/main" id="{AE67763A-F250-496E-ABDD-5936C0450DFF}"/>
+                <a16:creationId xmlns:a16="http://schemas.microsoft.com/office/drawing/2014/main" id="{74575F98-8FF9-4B17-A0EE-97E3E6B1ED18}"/>
               </a:ext>
             </a:extLst>
           </p:cNvPr>
@@ -16682,7 +16682,7 @@
           <p:cNvPr id="9" name="">
             <a:extLst xmlns:a="http://schemas.openxmlformats.org/drawingml/2006/main">
               <a:ext uri="{FF2B5EF4-FFF2-40B4-BE49-F238E27FC236}">
-                <a16:creationId xmlns:a16="http://schemas.microsoft.com/office/drawing/2014/main" id="{F2DCD60B-3299-49EE-A318-DD6844B28CAF}"/>
+                <a16:creationId xmlns:a16="http://schemas.microsoft.com/office/drawing/2014/main" id="{4650AEE8-9261-44C0-A78E-83564AD42EC0}"/>
               </a:ext>
             </a:extLst>
           </p:cNvPr>
@@ -16840,7 +16840,7 @@
           <p:cNvPr id="10" name="">
             <a:extLst xmlns:a="http://schemas.openxmlformats.org/drawingml/2006/main">
               <a:ext uri="{FF2B5EF4-FFF2-40B4-BE49-F238E27FC236}">
-                <a16:creationId xmlns:a16="http://schemas.microsoft.com/office/drawing/2014/main" id="{E2457736-9FF0-44C6-91F3-C3272136F8D1}"/>
+                <a16:creationId xmlns:a16="http://schemas.microsoft.com/office/drawing/2014/main" id="{CC5608A0-3DE9-467A-A37E-B967EBF13E48}"/>
               </a:ext>
             </a:extLst>
           </p:cNvPr>
@@ -16998,7 +16998,7 @@
           <p:cNvPr id="11" name="">
             <a:extLst xmlns:a="http://schemas.openxmlformats.org/drawingml/2006/main">
               <a:ext uri="{FF2B5EF4-FFF2-40B4-BE49-F238E27FC236}">
-                <a16:creationId xmlns:a16="http://schemas.microsoft.com/office/drawing/2014/main" id="{31F01C1D-AF67-4778-A46A-6C04FB8B9D3C}"/>
+                <a16:creationId xmlns:a16="http://schemas.microsoft.com/office/drawing/2014/main" id="{F4E074DC-EFA7-4BF7-B7C2-5E617D6621A0}"/>
               </a:ext>
             </a:extLst>
           </p:cNvPr>
@@ -17156,7 +17156,7 @@
           <p:cNvPr id="12" name="">
             <a:extLst xmlns:a="http://schemas.openxmlformats.org/drawingml/2006/main">
               <a:ext uri="{FF2B5EF4-FFF2-40B4-BE49-F238E27FC236}">
-                <a16:creationId xmlns:a16="http://schemas.microsoft.com/office/drawing/2014/main" id="{2942044D-C418-4531-A23F-C3C26F51D64E}"/>
+                <a16:creationId xmlns:a16="http://schemas.microsoft.com/office/drawing/2014/main" id="{DE2D0BA4-71CB-4220-865D-35AAFE8F1DAA}"/>
               </a:ext>
             </a:extLst>
           </p:cNvPr>
@@ -17314,7 +17314,7 @@
           <p:cNvPr id="13" name="">
             <a:extLst xmlns:a="http://schemas.openxmlformats.org/drawingml/2006/main">
               <a:ext uri="{FF2B5EF4-FFF2-40B4-BE49-F238E27FC236}">
-                <a16:creationId xmlns:a16="http://schemas.microsoft.com/office/drawing/2014/main" id="{89C8207E-F08D-41AD-BF6F-305B37D77013}"/>
+                <a16:creationId xmlns:a16="http://schemas.microsoft.com/office/drawing/2014/main" id="{84625F2C-1220-4F6E-B1F0-BFD5556DA62A}"/>
               </a:ext>
             </a:extLst>
           </p:cNvPr>
@@ -17462,7 +17462,7 @@
                 <a:ea typeface="Helvetica Neue"/>
                 <a:cs typeface="Helvetica Neue"/>
               </a:rPr>
-              <a:t>26 пропусков: 12 Firestore Emulator, 14 PowerShell. Внешние сервисы синтетические.</a:t>
+              <a:t>Без пропусков. В браузере: PDF → проверенные пары → расписание → verify.</a:t>
             </a:r>
           </a:p>
           <a:p xmlns:a="http://schemas.openxmlformats.org/drawingml/2006/main">
@@ -17485,7 +17485,7 @@
                 <a:ea typeface="Helvetica Neue"/>
                 <a:cs typeface="Helvetica Neue"/>
               </a:rPr>
-              <a:t>В браузере пройден локальный цикл до verify и повторной загрузки.</a:t>
+              <a:t>Пара 22:00–22:20 исключена: учебный блок начинается в 22:30.</a:t>
             </a:r>
           </a:p>
           <a:p xmlns:a="http://schemas.openxmlformats.org/drawingml/2006/main">
@@ -17508,7 +17508,7 @@
                 <a:ea typeface="Helvetica Neue"/>
                 <a:cs typeface="Helvetica Neue"/>
               </a:rPr>
-              <a:t>Качество Gemini и персональный cloud apply/verify эти проверки не подтверждают.</a:t>
+              <a:t>Качество Gemini OCR и запись в реальный Calendar ещё не подтверждены.</a:t>
             </a:r>
           </a:p>
         </p:txBody>
@@ -17518,7 +17518,7 @@
           <p:cNvPr id="14" name="">
             <a:extLst xmlns:a="http://schemas.openxmlformats.org/drawingml/2006/main">
               <a:ext uri="{FF2B5EF4-FFF2-40B4-BE49-F238E27FC236}">
-                <a16:creationId xmlns:a16="http://schemas.microsoft.com/office/drawing/2014/main" id="{05F3117F-2312-4A8E-8F8E-012EED53AA54}"/>
+                <a16:creationId xmlns:a16="http://schemas.microsoft.com/office/drawing/2014/main" id="{75AB921A-7FE6-4E5B-8FD7-0481BF3ED294}"/>
               </a:ext>
             </a:extLst>
           </p:cNvPr>
@@ -17674,7 +17674,7 @@
     </p:spTree>
     <p:extLst>
       <p:ext uri="{BB962C8B-B14F-4D97-AF65-F5344CB8AC3E}">
-        <p14:creationId xmlns:p14="http://schemas.microsoft.com/office/powerpoint/2010/main" val="1265632745"/>
+        <p14:creationId xmlns:p14="http://schemas.microsoft.com/office/powerpoint/2010/main" val="1062038731"/>
       </p:ext>
     </p:extLst>
   </p:cSld>

</xml_diff>